<commit_message>
Update True Randomness Testing & Random Number Generators presentation
</commit_message>
<xml_diff>
--- a/Presentations/4.True Randomness Testing & Random Number Generators.pptx
+++ b/Presentations/4.True Randomness Testing & Random Number Generators.pptx
@@ -1926,7 +1926,7 @@
           <a:p>
             <a:fld id="{5BCAD085-E8A6-8845-BD4E-CB4CCA059FC4}" type="datetimeFigureOut">
               <a:rPr lang="en-US" smtClean="0"/>
-              <a:t>2/27/26</a:t>
+              <a:t>3/5/26</a:t>
             </a:fld>
             <a:endParaRPr lang="en-US"/>
           </a:p>
@@ -2094,7 +2094,7 @@
           <a:p>
             <a:fld id="{5BCAD085-E8A6-8845-BD4E-CB4CCA059FC4}" type="datetimeFigureOut">
               <a:rPr lang="en-US" smtClean="0"/>
-              <a:t>2/27/26</a:t>
+              <a:t>3/5/26</a:t>
             </a:fld>
             <a:endParaRPr lang="en-US"/>
           </a:p>
@@ -2272,7 +2272,7 @@
           <a:p>
             <a:fld id="{5BCAD085-E8A6-8845-BD4E-CB4CCA059FC4}" type="datetimeFigureOut">
               <a:rPr lang="en-US" smtClean="0"/>
-              <a:t>2/27/26</a:t>
+              <a:t>3/5/26</a:t>
             </a:fld>
             <a:endParaRPr lang="en-US"/>
           </a:p>
@@ -2440,7 +2440,7 @@
           <a:p>
             <a:fld id="{5BCAD085-E8A6-8845-BD4E-CB4CCA059FC4}" type="datetimeFigureOut">
               <a:rPr lang="en-US" smtClean="0"/>
-              <a:t>2/27/26</a:t>
+              <a:t>3/5/26</a:t>
             </a:fld>
             <a:endParaRPr lang="en-US"/>
           </a:p>
@@ -2685,7 +2685,7 @@
           <a:p>
             <a:fld id="{5BCAD085-E8A6-8845-BD4E-CB4CCA059FC4}" type="datetimeFigureOut">
               <a:rPr lang="en-US" smtClean="0"/>
-              <a:t>2/27/26</a:t>
+              <a:t>3/5/26</a:t>
             </a:fld>
             <a:endParaRPr lang="en-US"/>
           </a:p>
@@ -2970,7 +2970,7 @@
           <a:p>
             <a:fld id="{5BCAD085-E8A6-8845-BD4E-CB4CCA059FC4}" type="datetimeFigureOut">
               <a:rPr lang="en-US" smtClean="0"/>
-              <a:t>2/27/26</a:t>
+              <a:t>3/5/26</a:t>
             </a:fld>
             <a:endParaRPr lang="en-US"/>
           </a:p>
@@ -3389,7 +3389,7 @@
           <a:p>
             <a:fld id="{5BCAD085-E8A6-8845-BD4E-CB4CCA059FC4}" type="datetimeFigureOut">
               <a:rPr lang="en-US" smtClean="0"/>
-              <a:t>2/27/26</a:t>
+              <a:t>3/5/26</a:t>
             </a:fld>
             <a:endParaRPr lang="en-US"/>
           </a:p>
@@ -3506,7 +3506,7 @@
           <a:p>
             <a:fld id="{5BCAD085-E8A6-8845-BD4E-CB4CCA059FC4}" type="datetimeFigureOut">
               <a:rPr lang="en-US" smtClean="0"/>
-              <a:t>2/27/26</a:t>
+              <a:t>3/5/26</a:t>
             </a:fld>
             <a:endParaRPr lang="en-US"/>
           </a:p>
@@ -3601,7 +3601,7 @@
           <a:p>
             <a:fld id="{5BCAD085-E8A6-8845-BD4E-CB4CCA059FC4}" type="datetimeFigureOut">
               <a:rPr lang="en-US" smtClean="0"/>
-              <a:t>2/27/26</a:t>
+              <a:t>3/5/26</a:t>
             </a:fld>
             <a:endParaRPr lang="en-US"/>
           </a:p>
@@ -3876,7 +3876,7 @@
           <a:p>
             <a:fld id="{5BCAD085-E8A6-8845-BD4E-CB4CCA059FC4}" type="datetimeFigureOut">
               <a:rPr lang="en-US" smtClean="0"/>
-              <a:t>2/27/26</a:t>
+              <a:t>3/5/26</a:t>
             </a:fld>
             <a:endParaRPr lang="en-US"/>
           </a:p>
@@ -4128,7 +4128,7 @@
           <a:p>
             <a:fld id="{5BCAD085-E8A6-8845-BD4E-CB4CCA059FC4}" type="datetimeFigureOut">
               <a:rPr lang="en-US" smtClean="0"/>
-              <a:t>2/27/26</a:t>
+              <a:t>3/5/26</a:t>
             </a:fld>
             <a:endParaRPr lang="en-US"/>
           </a:p>
@@ -4339,7 +4339,7 @@
           <a:p>
             <a:fld id="{5BCAD085-E8A6-8845-BD4E-CB4CCA059FC4}" type="datetimeFigureOut">
               <a:rPr lang="en-US" smtClean="0"/>
-              <a:t>2/27/26</a:t>
+              <a:t>3/5/26</a:t>
             </a:fld>
             <a:endParaRPr lang="en-US"/>
           </a:p>
@@ -16860,8 +16860,8 @@
         </p:nvSpPr>
         <p:spPr>
           <a:xfrm>
-            <a:off x="800079" y="6072491"/>
-            <a:ext cx="11059823" cy="370871"/>
+            <a:off x="800079" y="6065726"/>
+            <a:ext cx="11290078" cy="384401"/>
           </a:xfrm>
           <a:prstGeom prst="rect">
             <a:avLst/>
@@ -16886,13 +16886,49 @@
               </a:spcAft>
             </a:pPr>
             <a:r>
-              <a:rPr sz="2000" b="0">
+              <a:rPr sz="2000" b="0" dirty="0">
                 <a:solidFill>
                   <a:srgbClr val="8A92A8"/>
                 </a:solidFill>
                 <a:latin typeface="Inter"/>
               </a:rPr>
-              <a:t>"Random numbers are the sine qua non of modern computational systems and secure communications."</a:t>
+              <a:t>"Random numbers are the </a:t>
+            </a:r>
+            <a:r>
+              <a:rPr lang="en-US" sz="2000" b="1" dirty="0">
+                <a:solidFill>
+                  <a:srgbClr val="8A92A8"/>
+                </a:solidFill>
+                <a:latin typeface="Inter"/>
+              </a:rPr>
+              <a:t>"</a:t>
+            </a:r>
+            <a:r>
+              <a:rPr lang="en-US" sz="2400" b="1" dirty="0">
+                <a:solidFill>
+                  <a:schemeClr val="bg1"/>
+                </a:solidFill>
+                <a:latin typeface="Inter"/>
+              </a:rPr>
+              <a:t>must-have</a:t>
+            </a:r>
+            <a:r>
+              <a:rPr lang="en-US" sz="2000" b="1" dirty="0">
+                <a:solidFill>
+                  <a:srgbClr val="8A92A8"/>
+                </a:solidFill>
+                <a:latin typeface="Inter"/>
+              </a:rPr>
+              <a:t>”</a:t>
+            </a:r>
+            <a:r>
+              <a:rPr sz="2000" b="0" dirty="0">
+                <a:solidFill>
+                  <a:srgbClr val="8A92A8"/>
+                </a:solidFill>
+                <a:latin typeface="Inter"/>
+              </a:rPr>
+              <a:t> of modern computational systems and secure communications."</a:t>
             </a:r>
           </a:p>
         </p:txBody>

</xml_diff>

<commit_message>
Update presentations and add temporary files
</commit_message>
<xml_diff>
--- a/Presentations/4.True Randomness Testing & Random Number Generators.pptx
+++ b/Presentations/4.True Randomness Testing & Random Number Generators.pptx
@@ -14305,7 +14305,7 @@
         </p:nvSpPr>
         <p:spPr>
           <a:xfrm>
-            <a:off x="609584" y="972780"/>
+            <a:off x="2728669" y="826348"/>
             <a:ext cx="4857292" cy="413255"/>
           </a:xfrm>
           <a:prstGeom prst="rect">
@@ -14331,76 +14331,13 @@
               </a:spcAft>
             </a:pPr>
             <a:r>
-              <a:rPr sz="2400" b="1">
+              <a:rPr sz="2400" b="1" dirty="0">
                 <a:solidFill>
                   <a:srgbClr val="00D4FF"/>
                 </a:solidFill>
                 <a:latin typeface="Space Grotesk"/>
               </a:rPr>
               <a:t>Can We Generate True Randomness?</a:t>
-            </a:r>
-          </a:p>
-        </p:txBody>
-      </p:sp>
-      <p:sp>
-        <p:nvSpPr>
-          <p:cNvPr id="6" name="TextBox 5"/>
-          <p:cNvSpPr txBox="1"/>
-          <p:nvPr/>
-        </p:nvSpPr>
-        <p:spPr>
-          <a:xfrm>
-            <a:off x="647162" y="1518776"/>
-            <a:ext cx="3933726" cy="1373966"/>
-          </a:xfrm>
-          <a:prstGeom prst="rect">
-            <a:avLst/>
-          </a:prstGeom>
-          <a:noFill/>
-        </p:spPr>
-        <p:txBody>
-          <a:bodyPr wrap="square" lIns="73152" tIns="54864" rIns="73152" bIns="54864" anchor="ctr">
-            <a:spAutoFit/>
-          </a:bodyPr>
-          <a:lstStyle/>
-          <a:p>
-            <a:pPr algn="l">
-              <a:lnSpc>
-                <a:spcPts val="2535"/>
-              </a:lnSpc>
-              <a:spcBef>
-                <a:spcPts val="0"/>
-              </a:spcBef>
-              <a:spcAft>
-                <a:spcPts val="0"/>
-              </a:spcAft>
-            </a:pPr>
-            <a:r>
-              <a:rPr sz="2000" b="0" dirty="0">
-                <a:solidFill>
-                  <a:srgbClr val="B0B8D4"/>
-                </a:solidFill>
-                <a:latin typeface="Inter"/>
-              </a:rPr>
-              <a:t> The term </a:t>
-            </a:r>
-            <a:r>
-              <a:rPr sz="2000" b="1" dirty="0">
-                <a:solidFill>
-                  <a:srgbClr val="FFFFFF"/>
-                </a:solidFill>
-                <a:latin typeface="Inter"/>
-              </a:rPr>
-              <a:t>"Random Number Generator"</a:t>
-            </a:r>
-            <a:r>
-              <a:rPr sz="2000" b="0" dirty="0">
-                <a:solidFill>
-                  <a:srgbClr val="B0B8D4"/>
-                </a:solidFill>
-                <a:latin typeface="Inter"/>
-              </a:rPr>
-              <a:t> is fundamentally a mathematical and computational oxymoron. </a:t>
             </a:r>
           </a:p>
         </p:txBody>
@@ -14428,7 +14365,7 @@
         </p:blipFill>
         <p:spPr>
           <a:xfrm>
-            <a:off x="5858520" y="1031300"/>
+            <a:off x="5858520" y="1524785"/>
             <a:ext cx="304792" cy="216876"/>
           </a:xfrm>
           <a:prstGeom prst="rect">
@@ -14444,7 +14381,7 @@
         </p:nvSpPr>
         <p:spPr>
           <a:xfrm>
-            <a:off x="6353808" y="925497"/>
+            <a:off x="6353808" y="1418982"/>
             <a:ext cx="2795317" cy="418961"/>
           </a:xfrm>
           <a:prstGeom prst="rect">
@@ -14489,7 +14426,7 @@
         </p:nvSpPr>
         <p:spPr>
           <a:xfrm>
-            <a:off x="6353808" y="1435014"/>
+            <a:off x="6353808" y="1928499"/>
             <a:ext cx="5629134" cy="685800"/>
           </a:xfrm>
           <a:prstGeom prst="rect">
@@ -14564,7 +14501,7 @@
       </p:sp>
       <p:pic>
         <p:nvPicPr>
-          <p:cNvPr id="14" name="Picture 13" descr="image.png"/>
+          <p:cNvPr id="17" name="Picture 16" descr="image.png"/>
           <p:cNvPicPr>
             <a:picLocks noChangeAspect="1"/>
           </p:cNvPicPr>
@@ -14585,8 +14522,8 @@
         </p:blipFill>
         <p:spPr>
           <a:xfrm>
-            <a:off x="5858520" y="2507675"/>
-            <a:ext cx="304792" cy="216876"/>
+            <a:off x="114296" y="1460052"/>
+            <a:ext cx="304792" cy="246184"/>
           </a:xfrm>
           <a:prstGeom prst="rect">
             <a:avLst/>
@@ -14595,14 +14532,14 @@
       </p:pic>
       <p:sp>
         <p:nvSpPr>
-          <p:cNvPr id="15" name="TextBox 14"/>
+          <p:cNvPr id="18" name="TextBox 17"/>
           <p:cNvSpPr txBox="1"/>
           <p:nvPr/>
         </p:nvSpPr>
         <p:spPr>
           <a:xfrm>
-            <a:off x="6353808" y="2401871"/>
-            <a:ext cx="2361159" cy="418961"/>
+            <a:off x="609584" y="1368903"/>
+            <a:ext cx="2376805" cy="418961"/>
           </a:xfrm>
           <a:prstGeom prst="rect">
             <a:avLst/>
@@ -14633,21 +14570,21 @@
                 </a:solidFill>
                 <a:latin typeface="Inter"/>
               </a:rPr>
-              <a:t>Quantum Challenges</a:t>
-            </a:r>
-          </a:p>
-        </p:txBody>
-      </p:sp>
-      <p:sp>
-        <p:nvSpPr>
-          <p:cNvPr id="16" name="TextBox 15"/>
+              <a:t>Proving Randomness</a:t>
+            </a:r>
+          </a:p>
+        </p:txBody>
+      </p:sp>
+      <p:sp>
+        <p:nvSpPr>
+          <p:cNvPr id="19" name="TextBox 18"/>
           <p:cNvSpPr txBox="1"/>
           <p:nvPr/>
         </p:nvSpPr>
         <p:spPr>
           <a:xfrm>
-            <a:off x="6353808" y="2953532"/>
-            <a:ext cx="5629134" cy="1277786"/>
+            <a:off x="711181" y="1870961"/>
+            <a:ext cx="5629134" cy="976036"/>
           </a:xfrm>
           <a:prstGeom prst="rect">
             <a:avLst/>
@@ -14672,144 +14609,23 @@
               </a:spcAft>
             </a:pPr>
             <a:r>
-              <a:rPr b="0">
+              <a:rPr b="0" dirty="0">
                 <a:solidFill>
                   <a:srgbClr val="B0B8D4"/>
                 </a:solidFill>
                 <a:latin typeface="Inter"/>
               </a:rPr>
-              <a:t>Even physical processes, including quantum experiments, present challenges in definitively proving true randomness versus unpredictability due to entropy or incomplete system knowledge</a:t>
+              <a:t>Distinguishing true randomness from unpredictability remains a fundamental challenge in computational systems and cryptography</a:t>
             </a:r>
           </a:p>
         </p:txBody>
       </p:sp>
       <p:pic>
         <p:nvPicPr>
-          <p:cNvPr id="17" name="Picture 16" descr="image.png"/>
-          <p:cNvPicPr>
-            <a:picLocks noChangeAspect="1"/>
-          </p:cNvPicPr>
-          <p:nvPr/>
-        </p:nvPicPr>
-        <p:blipFill>
-          <a:blip r:embed="rId4" cstate="email">
-            <a:alphaModFix/>
-            <a:extLst>
-              <a:ext uri="{28A0092B-C50C-407E-A947-70E740481C1C}">
-                <a14:useLocalDpi xmlns:a14="http://schemas.microsoft.com/office/drawing/2010/main"/>
-              </a:ext>
-            </a:extLst>
-          </a:blip>
-          <a:stretch>
-            <a:fillRect/>
-          </a:stretch>
-        </p:blipFill>
-        <p:spPr>
-          <a:xfrm>
-            <a:off x="114296" y="3303363"/>
-            <a:ext cx="304792" cy="246184"/>
-          </a:xfrm>
-          <a:prstGeom prst="rect">
-            <a:avLst/>
-          </a:prstGeom>
-        </p:spPr>
-      </p:pic>
-      <p:sp>
-        <p:nvSpPr>
-          <p:cNvPr id="18" name="TextBox 17"/>
-          <p:cNvSpPr txBox="1"/>
-          <p:nvPr/>
-        </p:nvSpPr>
-        <p:spPr>
-          <a:xfrm>
-            <a:off x="609584" y="3212214"/>
-            <a:ext cx="2376805" cy="418961"/>
-          </a:xfrm>
-          <a:prstGeom prst="rect">
-            <a:avLst/>
-          </a:prstGeom>
-          <a:noFill/>
-        </p:spPr>
-        <p:txBody>
-          <a:bodyPr wrap="none" lIns="73152" tIns="54864" rIns="73152" bIns="54864" anchor="ctr">
-            <a:spAutoFit/>
-          </a:bodyPr>
-          <a:lstStyle/>
-          <a:p>
-            <a:pPr algn="l">
-              <a:lnSpc>
-                <a:spcPts val="2535"/>
-              </a:lnSpc>
-              <a:spcBef>
-                <a:spcPts val="0"/>
-              </a:spcBef>
-              <a:spcAft>
-                <a:spcPts val="780"/>
-              </a:spcAft>
-            </a:pPr>
-            <a:r>
-              <a:rPr sz="2000" b="1">
-                <a:solidFill>
-                  <a:srgbClr val="FFFFFF"/>
-                </a:solidFill>
-                <a:latin typeface="Inter"/>
-              </a:rPr>
-              <a:t>Proving Randomness</a:t>
-            </a:r>
-          </a:p>
-        </p:txBody>
-      </p:sp>
-      <p:sp>
-        <p:nvSpPr>
-          <p:cNvPr id="19" name="TextBox 18"/>
-          <p:cNvSpPr txBox="1"/>
-          <p:nvPr/>
-        </p:nvSpPr>
-        <p:spPr>
-          <a:xfrm>
-            <a:off x="609584" y="3743300"/>
-            <a:ext cx="5629134" cy="976036"/>
-          </a:xfrm>
-          <a:prstGeom prst="rect">
-            <a:avLst/>
-          </a:prstGeom>
-          <a:noFill/>
-        </p:spPr>
-        <p:txBody>
-          <a:bodyPr wrap="square" lIns="73152" tIns="54864" rIns="73152" bIns="54864" anchor="ctr">
-            <a:spAutoFit/>
-          </a:bodyPr>
-          <a:lstStyle/>
-          <a:p>
-            <a:pPr algn="l">
-              <a:lnSpc>
-                <a:spcPts val="2275"/>
-              </a:lnSpc>
-              <a:spcBef>
-                <a:spcPts val="0"/>
-              </a:spcBef>
-              <a:spcAft>
-                <a:spcPts val="0"/>
-              </a:spcAft>
-            </a:pPr>
-            <a:r>
-              <a:rPr b="0">
-                <a:solidFill>
-                  <a:srgbClr val="B0B8D4"/>
-                </a:solidFill>
-                <a:latin typeface="Inter"/>
-              </a:rPr>
-              <a:t>Distinguishing true randomness from unpredictability remains a fundamental challenge in computational systems and cryptography</a:t>
-            </a:r>
-          </a:p>
-        </p:txBody>
-      </p:sp>
-      <p:pic>
-        <p:nvPicPr>
-          <p:cNvPr id="20" name="Picture 19">
+          <p:cNvPr id="4" name="Picture 3">
             <a:extLst>
               <a:ext uri="{FF2B5EF4-FFF2-40B4-BE49-F238E27FC236}">
-                <a16:creationId xmlns:a16="http://schemas.microsoft.com/office/drawing/2014/main" id="{199891DE-4828-0516-95E8-38051C082609}"/>
+                <a16:creationId xmlns:a16="http://schemas.microsoft.com/office/drawing/2014/main" id="{ED2D42D6-6904-8DDE-56D9-0F00E850BC7D}"/>
               </a:ext>
             </a:extLst>
           </p:cNvPr>
@@ -14819,21 +14635,15 @@
           <p:nvPr/>
         </p:nvPicPr>
         <p:blipFill>
-          <a:blip r:embed="rId5" cstate="email">
-            <a:extLst>
-              <a:ext uri="{28A0092B-C50C-407E-A947-70E740481C1C}">
-                <a14:useLocalDpi xmlns:a14="http://schemas.microsoft.com/office/drawing/2010/main"/>
-              </a:ext>
-            </a:extLst>
-          </a:blip>
+          <a:blip r:embed="rId4"/>
           <a:stretch>
             <a:fillRect/>
           </a:stretch>
         </p:blipFill>
         <p:spPr>
           <a:xfrm>
-            <a:off x="1157103" y="4831461"/>
-            <a:ext cx="9607929" cy="1733389"/>
+            <a:off x="756725" y="2860535"/>
+            <a:ext cx="10854703" cy="3883166"/>
           </a:xfrm>
           <a:prstGeom prst="rect">
             <a:avLst/>
@@ -15905,10 +15715,10 @@
       </p:sp>
       <p:pic>
         <p:nvPicPr>
-          <p:cNvPr id="34" name="Picture 33">
+          <p:cNvPr id="16" name="Picture 15">
             <a:extLst>
               <a:ext uri="{FF2B5EF4-FFF2-40B4-BE49-F238E27FC236}">
-                <a16:creationId xmlns:a16="http://schemas.microsoft.com/office/drawing/2014/main" id="{EE5853D5-1E54-A1FC-B117-025C17136E40}"/>
+                <a16:creationId xmlns:a16="http://schemas.microsoft.com/office/drawing/2014/main" id="{8A4FCB3F-3844-BA00-4384-0E239E06B5B1}"/>
               </a:ext>
             </a:extLst>
           </p:cNvPr>
@@ -15931,8 +15741,8 @@
         </p:blipFill>
         <p:spPr>
           <a:xfrm>
-            <a:off x="609584" y="4109200"/>
-            <a:ext cx="10576158" cy="2133386"/>
+            <a:off x="952475" y="4469695"/>
+            <a:ext cx="10150954" cy="2095155"/>
           </a:xfrm>
           <a:prstGeom prst="rect">
             <a:avLst/>
@@ -16071,7 +15881,7 @@
         </p:nvSpPr>
         <p:spPr>
           <a:xfrm>
-            <a:off x="609584" y="1619250"/>
+            <a:off x="609584" y="748399"/>
             <a:ext cx="5181470" cy="1619250"/>
           </a:xfrm>
           <a:prstGeom prst="roundRect">
@@ -16134,7 +15944,7 @@
         </p:blipFill>
         <p:spPr>
           <a:xfrm>
-            <a:off x="838179" y="1930598"/>
+            <a:off x="838179" y="1059747"/>
             <a:ext cx="380990" cy="291703"/>
           </a:xfrm>
           <a:prstGeom prst="rect">
@@ -16150,7 +15960,7 @@
         </p:nvSpPr>
         <p:spPr>
           <a:xfrm>
-            <a:off x="1371565" y="1808451"/>
+            <a:off x="1371565" y="937600"/>
             <a:ext cx="4357475" cy="478849"/>
           </a:xfrm>
           <a:prstGeom prst="rect">
@@ -16195,7 +16005,7 @@
         </p:nvSpPr>
         <p:spPr>
           <a:xfrm>
-            <a:off x="1371565" y="2312897"/>
+            <a:off x="1371565" y="1442046"/>
             <a:ext cx="4190895" cy="708207"/>
           </a:xfrm>
           <a:prstGeom prst="rect">
@@ -16240,7 +16050,7 @@
         </p:nvSpPr>
         <p:spPr>
           <a:xfrm>
-            <a:off x="609584" y="3543300"/>
+            <a:off x="609584" y="2672449"/>
             <a:ext cx="5181470" cy="1619250"/>
           </a:xfrm>
           <a:prstGeom prst="roundRect">
@@ -16303,7 +16113,7 @@
         </p:blipFill>
         <p:spPr>
           <a:xfrm>
-            <a:off x="838179" y="3884414"/>
+            <a:off x="838179" y="3013563"/>
             <a:ext cx="380990" cy="232171"/>
           </a:xfrm>
           <a:prstGeom prst="rect">
@@ -16319,7 +16129,7 @@
         </p:nvSpPr>
         <p:spPr>
           <a:xfrm>
-            <a:off x="1371565" y="3732502"/>
+            <a:off x="1371565" y="2861651"/>
             <a:ext cx="1314719" cy="478849"/>
           </a:xfrm>
           <a:prstGeom prst="rect">
@@ -16364,7 +16174,7 @@
         </p:nvSpPr>
         <p:spPr>
           <a:xfrm>
-            <a:off x="1371565" y="4236946"/>
+            <a:off x="1371565" y="3366095"/>
             <a:ext cx="4190895" cy="708207"/>
           </a:xfrm>
           <a:prstGeom prst="rect">
@@ -16409,7 +16219,7 @@
         </p:nvSpPr>
         <p:spPr>
           <a:xfrm>
-            <a:off x="6400639" y="1790700"/>
+            <a:off x="6400639" y="919849"/>
             <a:ext cx="5181470" cy="1276350"/>
           </a:xfrm>
           <a:prstGeom prst="roundRect">
@@ -16472,7 +16282,7 @@
         </p:blipFill>
         <p:spPr>
           <a:xfrm>
-            <a:off x="6629234" y="2078235"/>
+            <a:off x="6629234" y="1207384"/>
             <a:ext cx="380990" cy="339328"/>
           </a:xfrm>
           <a:prstGeom prst="rect">
@@ -16488,7 +16298,7 @@
         </p:nvSpPr>
         <p:spPr>
           <a:xfrm>
-            <a:off x="7162620" y="1979901"/>
+            <a:off x="7162620" y="1109050"/>
             <a:ext cx="2443746" cy="478849"/>
           </a:xfrm>
           <a:prstGeom prst="rect">
@@ -16533,7 +16343,7 @@
         </p:nvSpPr>
         <p:spPr>
           <a:xfrm>
-            <a:off x="7162620" y="2460374"/>
+            <a:off x="7162620" y="1676608"/>
             <a:ext cx="5420843" cy="413255"/>
           </a:xfrm>
           <a:prstGeom prst="rect">
@@ -16596,7 +16406,7 @@
         </p:nvSpPr>
         <p:spPr>
           <a:xfrm>
-            <a:off x="6400639" y="3371850"/>
+            <a:off x="6400639" y="2500999"/>
             <a:ext cx="5181470" cy="1619250"/>
           </a:xfrm>
           <a:prstGeom prst="roundRect">
@@ -16659,7 +16469,7 @@
         </p:blipFill>
         <p:spPr>
           <a:xfrm>
-            <a:off x="6629234" y="3683198"/>
+            <a:off x="6629234" y="2812347"/>
             <a:ext cx="380990" cy="291703"/>
           </a:xfrm>
           <a:prstGeom prst="rect">
@@ -16675,7 +16485,7 @@
         </p:nvSpPr>
         <p:spPr>
           <a:xfrm>
-            <a:off x="7162620" y="3561052"/>
+            <a:off x="7162620" y="2690201"/>
             <a:ext cx="4370877" cy="478849"/>
           </a:xfrm>
           <a:prstGeom prst="rect">
@@ -16720,7 +16530,7 @@
         </p:nvSpPr>
         <p:spPr>
           <a:xfrm>
-            <a:off x="7162620" y="4065495"/>
+            <a:off x="7162620" y="3194644"/>
             <a:ext cx="4190895" cy="708207"/>
           </a:xfrm>
           <a:prstGeom prst="rect">
@@ -16757,182 +16567,42 @@
           </a:p>
         </p:txBody>
       </p:sp>
-      <p:sp>
-        <p:nvSpPr>
-          <p:cNvPr id="20" name="Rounded Rectangle 19"/>
-          <p:cNvSpPr/>
-          <p:nvPr/>
-        </p:nvSpPr>
-        <p:spPr>
-          <a:xfrm>
-            <a:off x="609584" y="5962650"/>
-            <a:ext cx="10972525" cy="590549"/>
-          </a:xfrm>
-          <a:prstGeom prst="roundRect">
-            <a:avLst>
-              <a:gd name="adj" fmla="val 25806"/>
-            </a:avLst>
-          </a:prstGeom>
-          <a:solidFill>
-            <a:srgbClr val="00D4FF">
-              <a:alpha val="8000"/>
-            </a:srgbClr>
-          </a:solidFill>
-          <a:ln>
-            <a:noFill/>
-          </a:ln>
-        </p:spPr>
-        <p:style>
-          <a:lnRef idx="1">
-            <a:schemeClr val="accent1"/>
-          </a:lnRef>
-          <a:fillRef idx="3">
-            <a:schemeClr val="accent1"/>
-          </a:fillRef>
-          <a:effectRef idx="2">
-            <a:schemeClr val="accent1"/>
-          </a:effectRef>
-          <a:fontRef idx="minor">
-            <a:schemeClr val="lt1"/>
-          </a:fontRef>
-        </p:style>
-        <p:txBody>
-          <a:bodyPr rtlCol="0" anchor="ctr"/>
-          <a:lstStyle/>
-          <a:p>
-            <a:pPr algn="ctr"/>
-            <a:endParaRPr sz="3600"/>
-          </a:p>
-        </p:txBody>
-      </p:sp>
-      <p:sp>
-        <p:nvSpPr>
-          <p:cNvPr id="21" name="Round Same Side Corner Rectangle 20"/>
-          <p:cNvSpPr/>
-          <p:nvPr/>
-        </p:nvSpPr>
-        <p:spPr>
-          <a:xfrm rot="16200000">
-            <a:off x="380350" y="6191884"/>
-            <a:ext cx="590549" cy="132080"/>
-          </a:xfrm>
-          <a:prstGeom prst="round2SameRect">
-            <a:avLst>
-              <a:gd name="adj1" fmla="val 50000"/>
-              <a:gd name="adj2" fmla="val 0"/>
-            </a:avLst>
-          </a:prstGeom>
-          <a:solidFill>
-            <a:srgbClr val="00D4FF"/>
-          </a:solidFill>
-          <a:ln>
-            <a:noFill/>
-          </a:ln>
-        </p:spPr>
-        <p:style>
-          <a:lnRef idx="1">
-            <a:schemeClr val="accent1"/>
-          </a:lnRef>
-          <a:fillRef idx="3">
-            <a:schemeClr val="accent1"/>
-          </a:fillRef>
-          <a:effectRef idx="2">
-            <a:schemeClr val="accent1"/>
-          </a:effectRef>
-          <a:fontRef idx="minor">
-            <a:schemeClr val="lt1"/>
-          </a:fontRef>
-        </p:style>
-        <p:txBody>
-          <a:bodyPr rtlCol="0" anchor="ctr"/>
-          <a:lstStyle/>
-          <a:p>
-            <a:pPr algn="ctr"/>
-            <a:endParaRPr sz="3600"/>
-          </a:p>
-        </p:txBody>
-      </p:sp>
-      <p:sp>
-        <p:nvSpPr>
-          <p:cNvPr id="22" name="TextBox 21"/>
-          <p:cNvSpPr txBox="1"/>
-          <p:nvPr/>
-        </p:nvSpPr>
-        <p:spPr>
-          <a:xfrm>
-            <a:off x="800079" y="6065726"/>
-            <a:ext cx="11290078" cy="384401"/>
-          </a:xfrm>
-          <a:prstGeom prst="rect">
-            <a:avLst/>
-          </a:prstGeom>
-          <a:noFill/>
-        </p:spPr>
-        <p:txBody>
-          <a:bodyPr wrap="none" lIns="73152" tIns="54864" rIns="73152" bIns="54864" anchor="ctr">
-            <a:spAutoFit/>
-          </a:bodyPr>
-          <a:lstStyle/>
-          <a:p>
-            <a:pPr algn="l">
-              <a:lnSpc>
-                <a:spcPts val="1950"/>
-              </a:lnSpc>
-              <a:spcBef>
-                <a:spcPts val="0"/>
-              </a:spcBef>
-              <a:spcAft>
-                <a:spcPts val="0"/>
-              </a:spcAft>
-            </a:pPr>
-            <a:r>
-              <a:rPr sz="2000" b="0" dirty="0">
-                <a:solidFill>
-                  <a:srgbClr val="8A92A8"/>
-                </a:solidFill>
-                <a:latin typeface="Inter"/>
-              </a:rPr>
-              <a:t>"Random numbers are the </a:t>
-            </a:r>
-            <a:r>
-              <a:rPr lang="en-US" sz="2000" b="1" dirty="0">
-                <a:solidFill>
-                  <a:srgbClr val="8A92A8"/>
-                </a:solidFill>
-                <a:latin typeface="Inter"/>
-              </a:rPr>
-              <a:t>"</a:t>
-            </a:r>
-            <a:r>
-              <a:rPr lang="en-US" sz="2400" b="1" dirty="0">
-                <a:solidFill>
-                  <a:schemeClr val="bg1"/>
-                </a:solidFill>
-                <a:latin typeface="Inter"/>
-              </a:rPr>
-              <a:t>must-have</a:t>
-            </a:r>
-            <a:r>
-              <a:rPr lang="en-US" sz="2000" b="1" dirty="0">
-                <a:solidFill>
-                  <a:srgbClr val="8A92A8"/>
-                </a:solidFill>
-                <a:latin typeface="Inter"/>
-              </a:rPr>
-              <a:t>”</a:t>
-            </a:r>
-            <a:r>
-              <a:rPr sz="2000" b="0" dirty="0">
-                <a:solidFill>
-                  <a:srgbClr val="8A92A8"/>
-                </a:solidFill>
-                <a:latin typeface="Inter"/>
-              </a:rPr>
-              <a:t> of modern computational systems and secure communications."</a:t>
-            </a:r>
-          </a:p>
-        </p:txBody>
-      </p:sp>
+      <p:pic>
+        <p:nvPicPr>
+          <p:cNvPr id="23" name="Picture 22">
+            <a:extLst>
+              <a:ext uri="{FF2B5EF4-FFF2-40B4-BE49-F238E27FC236}">
+                <a16:creationId xmlns:a16="http://schemas.microsoft.com/office/drawing/2014/main" id="{7FCBA89F-91C8-E32C-BEF6-5C617B3806F1}"/>
+              </a:ext>
+            </a:extLst>
+          </p:cNvPr>
+          <p:cNvPicPr>
+            <a:picLocks noChangeAspect="1"/>
+          </p:cNvPicPr>
+          <p:nvPr/>
+        </p:nvPicPr>
+        <p:blipFill>
+          <a:blip r:embed="rId6" cstate="email">
+            <a:extLst>
+              <a:ext uri="{28A0092B-C50C-407E-A947-70E740481C1C}">
+                <a14:useLocalDpi xmlns:a14="http://schemas.microsoft.com/office/drawing/2010/main"/>
+              </a:ext>
+            </a:extLst>
+          </a:blip>
+          <a:stretch>
+            <a:fillRect/>
+          </a:stretch>
+        </p:blipFill>
+        <p:spPr>
+          <a:xfrm>
+            <a:off x="838179" y="4478577"/>
+            <a:ext cx="10576158" cy="2133386"/>
+          </a:xfrm>
+          <a:prstGeom prst="rect">
+            <a:avLst/>
+          </a:prstGeom>
+        </p:spPr>
+      </p:pic>
     </p:spTree>
   </p:cSld>
   <p:clrMapOvr>

</xml_diff>

<commit_message>
Update project files and remove compressed samples
</commit_message>
<xml_diff>
--- a/Presentations/4.True Randomness Testing & Random Number Generators.pptx
+++ b/Presentations/4.True Randomness Testing & Random Number Generators.pptx
@@ -15104,7 +15104,7 @@
         <p:spPr>
           <a:xfrm>
             <a:off x="1257268" y="3833883"/>
-            <a:ext cx="1431867" cy="418961"/>
+            <a:ext cx="1712072" cy="418961"/>
           </a:xfrm>
           <a:prstGeom prst="rect">
             <a:avLst/>
@@ -15129,14 +15129,20 @@
               </a:spcAft>
             </a:pPr>
             <a:r>
-              <a:rPr sz="2000" b="1">
+              <a:rPr lang="en-US" sz="2000" b="1" dirty="0">
                 <a:solidFill>
                   <a:srgbClr val="FFFFFF"/>
                 </a:solidFill>
                 <a:latin typeface="Space Grotesk"/>
               </a:rPr>
-              <a:t>Critical Goal</a:t>
-            </a:r>
+              <a:t>Very Basic Test</a:t>
+            </a:r>
+            <a:endParaRPr sz="2000" b="1" dirty="0">
+              <a:solidFill>
+                <a:srgbClr val="FFFFFF"/>
+              </a:solidFill>
+              <a:latin typeface="Space Grotesk"/>
+            </a:endParaRPr>
           </a:p>
         </p:txBody>
       </p:sp>
@@ -15148,8 +15154,8 @@
         </p:nvSpPr>
         <p:spPr>
           <a:xfrm>
-            <a:off x="876278" y="4381499"/>
-            <a:ext cx="5705332" cy="714375"/>
+            <a:off x="876278" y="4375510"/>
+            <a:ext cx="5705332" cy="726353"/>
           </a:xfrm>
           <a:prstGeom prst="rect">
             <a:avLst/>
@@ -15174,32 +15180,65 @@
               </a:spcAft>
             </a:pPr>
             <a:r>
-              <a:rPr b="0">
+              <a:rPr lang="en-US" sz="2000" dirty="0">
                 <a:solidFill>
                   <a:srgbClr val="B0B8D4"/>
                 </a:solidFill>
                 <a:latin typeface="Inter"/>
               </a:rPr>
-              <a:t> Minimize </a:t>
-            </a:r>
-            <a:r>
-              <a:rPr b="0">
-                <a:solidFill>
-                  <a:srgbClr val="00D4FF"/>
+              <a:t>O</a:t>
+            </a:r>
+            <a:r>
+              <a:rPr lang="en-US" sz="2000" b="0" dirty="0">
+                <a:solidFill>
+                  <a:srgbClr val="B0B8D4"/>
                 </a:solidFill>
                 <a:latin typeface="Inter"/>
               </a:rPr>
-              <a:t>Type II errors</a:t>
-            </a:r>
-            <a:r>
-              <a:rPr b="0">
+              <a:t>ne of the best ways to measure how </a:t>
+            </a:r>
+            <a:r>
+              <a:rPr lang="en-US" sz="2000" b="1" dirty="0">
+                <a:solidFill>
+                  <a:schemeClr val="bg1"/>
+                </a:solidFill>
+                <a:latin typeface="Inter"/>
+              </a:rPr>
+              <a:t>random</a:t>
+            </a:r>
+            <a:r>
+              <a:rPr lang="en-US" sz="2000" b="0" dirty="0">
                 <a:solidFill>
                   <a:srgbClr val="B0B8D4"/>
                 </a:solidFill>
                 <a:latin typeface="Inter"/>
               </a:rPr>
-              <a:t> — rejecting the null hypothesis when it's actually false </a:t>
-            </a:r>
+              <a:t> a file is involves trying to </a:t>
+            </a:r>
+            <a:r>
+              <a:rPr lang="en-US" sz="2000" b="1" dirty="0">
+                <a:solidFill>
+                  <a:schemeClr val="bg1"/>
+                </a:solidFill>
+                <a:latin typeface="Inter"/>
+              </a:rPr>
+              <a:t>compress</a:t>
+            </a:r>
+            <a:r>
+              <a:rPr lang="en-US" sz="2000" b="0" dirty="0">
+                <a:solidFill>
+                  <a:srgbClr val="B0B8D4"/>
+                </a:solidFill>
+                <a:latin typeface="Inter"/>
+              </a:rPr>
+              <a:t> it.</a:t>
+            </a:r>
+            <a:endParaRPr sz="2000" b="0" dirty="0">
+              <a:solidFill>
+                <a:srgbClr val="B0B8D4"/>
+              </a:solidFill>
+              <a:latin typeface="Inter"/>
+            </a:endParaRPr>
           </a:p>
         </p:txBody>
       </p:sp>

</xml_diff>

<commit_message>
Update presentations and QRNG test files
</commit_message>
<xml_diff>
--- a/Presentations/4.True Randomness Testing & Random Number Generators.pptx
+++ b/Presentations/4.True Randomness Testing & Random Number Generators.pptx
@@ -11866,8 +11866,8 @@
         </p:nvSpPr>
         <p:spPr>
           <a:xfrm>
-            <a:off x="609584" y="116607"/>
-            <a:ext cx="3126177" cy="566886"/>
+            <a:off x="609584" y="117184"/>
+            <a:ext cx="2379113" cy="565732"/>
           </a:xfrm>
           <a:prstGeom prst="rect">
             <a:avLst/>
@@ -11880,74 +11880,735 @@
           </a:bodyPr>
           <a:lstStyle/>
           <a:p>
-            <a:pPr algn="l">
+            <a:pPr>
               <a:lnSpc>
                 <a:spcPts val="3900"/>
               </a:lnSpc>
-              <a:spcBef>
-                <a:spcPts val="0"/>
-              </a:spcBef>
-              <a:spcAft>
-                <a:spcPts val="0"/>
-              </a:spcAft>
             </a:pPr>
             <a:r>
-              <a:rPr lang="en-US" sz="2392" b="1" dirty="0">
-                <a:solidFill>
-                  <a:srgbClr val="FFFFFF"/>
-                </a:solidFill>
-                <a:latin typeface="Space Grotesk"/>
-              </a:rPr>
-              <a:t>Strategy of </a:t>
-            </a:r>
-            <a:r>
-              <a:rPr sz="2392" b="1" dirty="0">
-                <a:solidFill>
-                  <a:srgbClr val="FFFFFF"/>
-                </a:solidFill>
-                <a:latin typeface="Space Grotesk"/>
-              </a:rPr>
-              <a:t>RNG Testing</a:t>
-            </a:r>
-          </a:p>
-        </p:txBody>
-      </p:sp>
-      <p:pic>
-        <p:nvPicPr>
-          <p:cNvPr id="29" name="Picture 28">
+              <a:rPr lang="en-US" sz="2400" b="1" dirty="0">
+                <a:solidFill>
+                  <a:schemeClr val="bg1"/>
+                </a:solidFill>
+                <a:latin typeface="Menlo" panose="020B0609030804020204" pitchFamily="49" charset="0"/>
+              </a:rPr>
+              <a:t>Useful Links</a:t>
+            </a:r>
+            <a:endParaRPr sz="2392" b="1" dirty="0">
+              <a:solidFill>
+                <a:srgbClr val="FFFFFF"/>
+              </a:solidFill>
+              <a:latin typeface="Space Grotesk"/>
+            </a:endParaRPr>
+          </a:p>
+        </p:txBody>
+      </p:sp>
+      <p:sp>
+        <p:nvSpPr>
+          <p:cNvPr id="5" name="TextBox 4">
             <a:extLst>
               <a:ext uri="{FF2B5EF4-FFF2-40B4-BE49-F238E27FC236}">
-                <a16:creationId xmlns:a16="http://schemas.microsoft.com/office/drawing/2014/main" id="{FB01ED16-AAC6-1EAE-A9F5-78120C48B8A9}"/>
+                <a16:creationId xmlns:a16="http://schemas.microsoft.com/office/drawing/2014/main" id="{F9840C30-7B45-C288-3018-5068157CE3BE}"/>
               </a:ext>
             </a:extLst>
           </p:cNvPr>
-          <p:cNvPicPr>
-            <a:picLocks noChangeAspect="1"/>
-          </p:cNvPicPr>
-          <p:nvPr/>
-        </p:nvPicPr>
-        <p:blipFill>
-          <a:blip r:embed="rId2" cstate="email">
-            <a:extLst>
-              <a:ext uri="{28A0092B-C50C-407E-A947-70E740481C1C}">
-                <a14:useLocalDpi xmlns:a14="http://schemas.microsoft.com/office/drawing/2010/main"/>
-              </a:ext>
-            </a:extLst>
-          </a:blip>
-          <a:stretch>
-            <a:fillRect/>
-          </a:stretch>
-        </p:blipFill>
-        <p:spPr>
-          <a:xfrm>
-            <a:off x="471689" y="1778696"/>
-            <a:ext cx="10928455" cy="3883068"/>
-          </a:xfrm>
-          <a:prstGeom prst="rect">
-            <a:avLst/>
-          </a:prstGeom>
-        </p:spPr>
-      </p:pic>
+          <p:cNvSpPr txBox="1"/>
+          <p:nvPr/>
+        </p:nvSpPr>
+        <p:spPr>
+          <a:xfrm>
+            <a:off x="609583" y="953482"/>
+            <a:ext cx="11253865" cy="4237699"/>
+          </a:xfrm>
+          <a:prstGeom prst="rect">
+            <a:avLst/>
+          </a:prstGeom>
+          <a:noFill/>
+        </p:spPr>
+        <p:txBody>
+          <a:bodyPr wrap="square">
+            <a:spAutoFit/>
+          </a:bodyPr>
+          <a:lstStyle/>
+          <a:p>
+            <a:pPr>
+              <a:lnSpc>
+                <a:spcPts val="1350"/>
+              </a:lnSpc>
+              <a:buNone/>
+            </a:pPr>
+            <a:endParaRPr lang="en-US" b="0" dirty="0">
+              <a:solidFill>
+                <a:schemeClr val="bg1"/>
+              </a:solidFill>
+              <a:effectLst/>
+              <a:latin typeface="Calibri" panose="020F0502020204030204" pitchFamily="34" charset="0"/>
+              <a:cs typeface="Calibri" panose="020F0502020204030204" pitchFamily="34" charset="0"/>
+            </a:endParaRPr>
+          </a:p>
+          <a:p>
+            <a:pPr>
+              <a:lnSpc>
+                <a:spcPts val="1350"/>
+              </a:lnSpc>
+              <a:buNone/>
+            </a:pPr>
+            <a:br>
+              <a:rPr lang="en-US" b="0" dirty="0">
+                <a:solidFill>
+                  <a:schemeClr val="bg1"/>
+                </a:solidFill>
+                <a:effectLst/>
+                <a:latin typeface="Calibri" panose="020F0502020204030204" pitchFamily="34" charset="0"/>
+                <a:cs typeface="Calibri" panose="020F0502020204030204" pitchFamily="34" charset="0"/>
+              </a:rPr>
+            </a:br>
+            <a:endParaRPr lang="en-US" b="0" dirty="0">
+              <a:solidFill>
+                <a:schemeClr val="bg1"/>
+              </a:solidFill>
+              <a:effectLst/>
+              <a:latin typeface="Calibri" panose="020F0502020204030204" pitchFamily="34" charset="0"/>
+              <a:cs typeface="Calibri" panose="020F0502020204030204" pitchFamily="34" charset="0"/>
+            </a:endParaRPr>
+          </a:p>
+          <a:p>
+            <a:pPr>
+              <a:lnSpc>
+                <a:spcPts val="1350"/>
+              </a:lnSpc>
+              <a:buNone/>
+            </a:pPr>
+            <a:r>
+              <a:rPr lang="en-US" sz="2800" b="1" dirty="0">
+                <a:solidFill>
+                  <a:schemeClr val="bg1"/>
+                </a:solidFill>
+                <a:effectLst/>
+                <a:latin typeface="Calibri" panose="020F0502020204030204" pitchFamily="34" charset="0"/>
+                <a:cs typeface="Calibri" panose="020F0502020204030204" pitchFamily="34" charset="0"/>
+              </a:rPr>
+              <a:t>NIST-Statistical-Test-Suite</a:t>
+            </a:r>
+            <a:r>
+              <a:rPr lang="en-US" b="1" dirty="0">
+                <a:solidFill>
+                  <a:schemeClr val="bg1"/>
+                </a:solidFill>
+                <a:effectLst/>
+                <a:latin typeface="Calibri" panose="020F0502020204030204" pitchFamily="34" charset="0"/>
+                <a:cs typeface="Calibri" panose="020F0502020204030204" pitchFamily="34" charset="0"/>
+              </a:rPr>
+              <a:t> </a:t>
+            </a:r>
+            <a:endParaRPr lang="en-US" b="0" dirty="0">
+              <a:solidFill>
+                <a:schemeClr val="bg1"/>
+              </a:solidFill>
+              <a:effectLst/>
+              <a:latin typeface="Calibri" panose="020F0502020204030204" pitchFamily="34" charset="0"/>
+              <a:cs typeface="Calibri" panose="020F0502020204030204" pitchFamily="34" charset="0"/>
+            </a:endParaRPr>
+          </a:p>
+          <a:p>
+            <a:pPr>
+              <a:lnSpc>
+                <a:spcPts val="1350"/>
+              </a:lnSpc>
+              <a:buNone/>
+            </a:pPr>
+            <a:r>
+              <a:rPr lang="en-US" b="0" u="sng" dirty="0">
+                <a:solidFill>
+                  <a:schemeClr val="bg1"/>
+                </a:solidFill>
+                <a:effectLst/>
+                <a:latin typeface="Calibri" panose="020F0502020204030204" pitchFamily="34" charset="0"/>
+                <a:cs typeface="Calibri" panose="020F0502020204030204" pitchFamily="34" charset="0"/>
+              </a:rPr>
+              <a:t>https://</a:t>
+            </a:r>
+            <a:r>
+              <a:rPr lang="en-US" b="0" u="sng" dirty="0" err="1">
+                <a:solidFill>
+                  <a:schemeClr val="bg1"/>
+                </a:solidFill>
+                <a:effectLst/>
+                <a:latin typeface="Calibri" panose="020F0502020204030204" pitchFamily="34" charset="0"/>
+                <a:cs typeface="Calibri" panose="020F0502020204030204" pitchFamily="34" charset="0"/>
+              </a:rPr>
+              <a:t>csrc.nist.gov</a:t>
+            </a:r>
+            <a:r>
+              <a:rPr lang="en-US" b="0" u="sng" dirty="0">
+                <a:solidFill>
+                  <a:schemeClr val="bg1"/>
+                </a:solidFill>
+                <a:effectLst/>
+                <a:latin typeface="Calibri" panose="020F0502020204030204" pitchFamily="34" charset="0"/>
+                <a:cs typeface="Calibri" panose="020F0502020204030204" pitchFamily="34" charset="0"/>
+              </a:rPr>
+              <a:t>/Projects/random-bit-generation/Documentation-and-Software/Guide-to-the-Statistical-Tests</a:t>
+            </a:r>
+          </a:p>
+          <a:p>
+            <a:pPr>
+              <a:lnSpc>
+                <a:spcPts val="1350"/>
+              </a:lnSpc>
+              <a:buNone/>
+            </a:pPr>
+            <a:endParaRPr lang="en-US" b="0" dirty="0">
+              <a:solidFill>
+                <a:schemeClr val="bg1"/>
+              </a:solidFill>
+              <a:effectLst/>
+              <a:latin typeface="Calibri" panose="020F0502020204030204" pitchFamily="34" charset="0"/>
+              <a:cs typeface="Calibri" panose="020F0502020204030204" pitchFamily="34" charset="0"/>
+            </a:endParaRPr>
+          </a:p>
+          <a:p>
+            <a:pPr>
+              <a:lnSpc>
+                <a:spcPts val="1350"/>
+              </a:lnSpc>
+              <a:buNone/>
+            </a:pPr>
+            <a:r>
+              <a:rPr lang="en-US" b="0" u="sng" dirty="0">
+                <a:solidFill>
+                  <a:schemeClr val="bg1"/>
+                </a:solidFill>
+                <a:effectLst/>
+                <a:latin typeface="Calibri" panose="020F0502020204030204" pitchFamily="34" charset="0"/>
+                <a:cs typeface="Calibri" panose="020F0502020204030204" pitchFamily="34" charset="0"/>
+              </a:rPr>
+              <a:t>https://</a:t>
+            </a:r>
+            <a:r>
+              <a:rPr lang="en-US" b="0" u="sng" dirty="0" err="1">
+                <a:solidFill>
+                  <a:schemeClr val="bg1"/>
+                </a:solidFill>
+                <a:effectLst/>
+                <a:latin typeface="Calibri" panose="020F0502020204030204" pitchFamily="34" charset="0"/>
+                <a:cs typeface="Calibri" panose="020F0502020204030204" pitchFamily="34" charset="0"/>
+              </a:rPr>
+              <a:t>github.com</a:t>
+            </a:r>
+            <a:r>
+              <a:rPr lang="en-US" b="0" u="sng" dirty="0">
+                <a:solidFill>
+                  <a:schemeClr val="bg1"/>
+                </a:solidFill>
+                <a:effectLst/>
+                <a:latin typeface="Calibri" panose="020F0502020204030204" pitchFamily="34" charset="0"/>
+                <a:cs typeface="Calibri" panose="020F0502020204030204" pitchFamily="34" charset="0"/>
+              </a:rPr>
+              <a:t>/</a:t>
+            </a:r>
+            <a:r>
+              <a:rPr lang="en-US" b="0" u="sng" dirty="0" err="1">
+                <a:solidFill>
+                  <a:schemeClr val="bg1"/>
+                </a:solidFill>
+                <a:effectLst/>
+                <a:latin typeface="Calibri" panose="020F0502020204030204" pitchFamily="34" charset="0"/>
+                <a:cs typeface="Calibri" panose="020F0502020204030204" pitchFamily="34" charset="0"/>
+              </a:rPr>
+              <a:t>terrillmoore</a:t>
+            </a:r>
+            <a:r>
+              <a:rPr lang="en-US" b="0" u="sng" dirty="0">
+                <a:solidFill>
+                  <a:schemeClr val="bg1"/>
+                </a:solidFill>
+                <a:effectLst/>
+                <a:latin typeface="Calibri" panose="020F0502020204030204" pitchFamily="34" charset="0"/>
+                <a:cs typeface="Calibri" panose="020F0502020204030204" pitchFamily="34" charset="0"/>
+              </a:rPr>
+              <a:t>/NIST-Statistical-Test-Suite</a:t>
+            </a:r>
+          </a:p>
+          <a:p>
+            <a:pPr>
+              <a:lnSpc>
+                <a:spcPts val="1350"/>
+              </a:lnSpc>
+              <a:buNone/>
+            </a:pPr>
+            <a:br>
+              <a:rPr lang="en-US" b="0" dirty="0">
+                <a:solidFill>
+                  <a:schemeClr val="bg1"/>
+                </a:solidFill>
+                <a:effectLst/>
+                <a:latin typeface="Calibri" panose="020F0502020204030204" pitchFamily="34" charset="0"/>
+                <a:cs typeface="Calibri" panose="020F0502020204030204" pitchFamily="34" charset="0"/>
+              </a:rPr>
+            </a:br>
+            <a:endParaRPr lang="en-US" b="0" dirty="0">
+              <a:solidFill>
+                <a:schemeClr val="bg1"/>
+              </a:solidFill>
+              <a:effectLst/>
+              <a:latin typeface="Calibri" panose="020F0502020204030204" pitchFamily="34" charset="0"/>
+              <a:cs typeface="Calibri" panose="020F0502020204030204" pitchFamily="34" charset="0"/>
+            </a:endParaRPr>
+          </a:p>
+          <a:p>
+            <a:pPr>
+              <a:lnSpc>
+                <a:spcPts val="1350"/>
+              </a:lnSpc>
+              <a:buNone/>
+            </a:pPr>
+            <a:r>
+              <a:rPr lang="en-US" sz="2800" b="1" dirty="0" err="1">
+                <a:solidFill>
+                  <a:schemeClr val="bg1"/>
+                </a:solidFill>
+                <a:effectLst/>
+                <a:latin typeface="Calibri" panose="020F0502020204030204" pitchFamily="34" charset="0"/>
+                <a:cs typeface="Calibri" panose="020F0502020204030204" pitchFamily="34" charset="0"/>
+              </a:rPr>
+              <a:t>dieharder</a:t>
+            </a:r>
+            <a:r>
+              <a:rPr lang="en-US" sz="2800" b="1" dirty="0">
+                <a:solidFill>
+                  <a:schemeClr val="bg1"/>
+                </a:solidFill>
+                <a:effectLst/>
+                <a:latin typeface="Calibri" panose="020F0502020204030204" pitchFamily="34" charset="0"/>
+                <a:cs typeface="Calibri" panose="020F0502020204030204" pitchFamily="34" charset="0"/>
+              </a:rPr>
+              <a:t>-Robert G. Brown</a:t>
+            </a:r>
+            <a:endParaRPr lang="en-US" sz="2800" b="0" dirty="0">
+              <a:solidFill>
+                <a:schemeClr val="bg1"/>
+              </a:solidFill>
+              <a:effectLst/>
+              <a:latin typeface="Calibri" panose="020F0502020204030204" pitchFamily="34" charset="0"/>
+              <a:cs typeface="Calibri" panose="020F0502020204030204" pitchFamily="34" charset="0"/>
+            </a:endParaRPr>
+          </a:p>
+          <a:p>
+            <a:pPr>
+              <a:lnSpc>
+                <a:spcPts val="1350"/>
+              </a:lnSpc>
+              <a:buNone/>
+            </a:pPr>
+            <a:r>
+              <a:rPr lang="en-US" b="0" u="sng" dirty="0">
+                <a:solidFill>
+                  <a:schemeClr val="bg1"/>
+                </a:solidFill>
+                <a:effectLst/>
+                <a:latin typeface="Calibri" panose="020F0502020204030204" pitchFamily="34" charset="0"/>
+                <a:cs typeface="Calibri" panose="020F0502020204030204" pitchFamily="34" charset="0"/>
+              </a:rPr>
+              <a:t>https://</a:t>
+            </a:r>
+            <a:r>
+              <a:rPr lang="en-US" b="0" u="sng" dirty="0" err="1">
+                <a:solidFill>
+                  <a:schemeClr val="bg1"/>
+                </a:solidFill>
+                <a:effectLst/>
+                <a:latin typeface="Calibri" panose="020F0502020204030204" pitchFamily="34" charset="0"/>
+                <a:cs typeface="Calibri" panose="020F0502020204030204" pitchFamily="34" charset="0"/>
+              </a:rPr>
+              <a:t>webhome.phy.duke.edu</a:t>
+            </a:r>
+            <a:r>
+              <a:rPr lang="en-US" b="0" u="sng" dirty="0">
+                <a:solidFill>
+                  <a:schemeClr val="bg1"/>
+                </a:solidFill>
+                <a:effectLst/>
+                <a:latin typeface="Calibri" panose="020F0502020204030204" pitchFamily="34" charset="0"/>
+                <a:cs typeface="Calibri" panose="020F0502020204030204" pitchFamily="34" charset="0"/>
+              </a:rPr>
+              <a:t>/~</a:t>
+            </a:r>
+            <a:r>
+              <a:rPr lang="en-US" b="0" u="sng" dirty="0" err="1">
+                <a:solidFill>
+                  <a:schemeClr val="bg1"/>
+                </a:solidFill>
+                <a:effectLst/>
+                <a:latin typeface="Calibri" panose="020F0502020204030204" pitchFamily="34" charset="0"/>
+                <a:cs typeface="Calibri" panose="020F0502020204030204" pitchFamily="34" charset="0"/>
+              </a:rPr>
+              <a:t>rgb</a:t>
+            </a:r>
+            <a:r>
+              <a:rPr lang="en-US" b="0" u="sng" dirty="0">
+                <a:solidFill>
+                  <a:schemeClr val="bg1"/>
+                </a:solidFill>
+                <a:effectLst/>
+                <a:latin typeface="Calibri" panose="020F0502020204030204" pitchFamily="34" charset="0"/>
+                <a:cs typeface="Calibri" panose="020F0502020204030204" pitchFamily="34" charset="0"/>
+              </a:rPr>
+              <a:t>/General/</a:t>
+            </a:r>
+            <a:r>
+              <a:rPr lang="en-US" b="0" u="sng" dirty="0" err="1">
+                <a:solidFill>
+                  <a:schemeClr val="bg1"/>
+                </a:solidFill>
+                <a:effectLst/>
+                <a:latin typeface="Calibri" panose="020F0502020204030204" pitchFamily="34" charset="0"/>
+                <a:cs typeface="Calibri" panose="020F0502020204030204" pitchFamily="34" charset="0"/>
+              </a:rPr>
+              <a:t>dieharder.php</a:t>
+            </a:r>
+            <a:endParaRPr lang="en-US" b="0" u="sng" dirty="0">
+              <a:solidFill>
+                <a:schemeClr val="bg1"/>
+              </a:solidFill>
+              <a:effectLst/>
+              <a:latin typeface="Calibri" panose="020F0502020204030204" pitchFamily="34" charset="0"/>
+              <a:cs typeface="Calibri" panose="020F0502020204030204" pitchFamily="34" charset="0"/>
+            </a:endParaRPr>
+          </a:p>
+          <a:p>
+            <a:pPr>
+              <a:lnSpc>
+                <a:spcPts val="1350"/>
+              </a:lnSpc>
+              <a:buNone/>
+            </a:pPr>
+            <a:endParaRPr lang="en-US" b="0" u="sng" dirty="0">
+              <a:solidFill>
+                <a:schemeClr val="bg1"/>
+              </a:solidFill>
+              <a:effectLst/>
+              <a:latin typeface="Calibri" panose="020F0502020204030204" pitchFamily="34" charset="0"/>
+              <a:cs typeface="Calibri" panose="020F0502020204030204" pitchFamily="34" charset="0"/>
+            </a:endParaRPr>
+          </a:p>
+          <a:p>
+            <a:pPr>
+              <a:lnSpc>
+                <a:spcPts val="1350"/>
+              </a:lnSpc>
+              <a:buNone/>
+            </a:pPr>
+            <a:r>
+              <a:rPr lang="en-US" b="0" u="sng" dirty="0">
+                <a:solidFill>
+                  <a:schemeClr val="bg1"/>
+                </a:solidFill>
+                <a:effectLst/>
+                <a:latin typeface="Calibri" panose="020F0502020204030204" pitchFamily="34" charset="0"/>
+                <a:cs typeface="Calibri" panose="020F0502020204030204" pitchFamily="34" charset="0"/>
+              </a:rPr>
+              <a:t>https://</a:t>
+            </a:r>
+            <a:r>
+              <a:rPr lang="en-US" b="0" u="sng" dirty="0" err="1">
+                <a:solidFill>
+                  <a:schemeClr val="bg1"/>
+                </a:solidFill>
+                <a:effectLst/>
+                <a:latin typeface="Calibri" panose="020F0502020204030204" pitchFamily="34" charset="0"/>
+                <a:cs typeface="Calibri" panose="020F0502020204030204" pitchFamily="34" charset="0"/>
+              </a:rPr>
+              <a:t>github.com</a:t>
+            </a:r>
+            <a:r>
+              <a:rPr lang="en-US" b="0" u="sng" dirty="0">
+                <a:solidFill>
+                  <a:schemeClr val="bg1"/>
+                </a:solidFill>
+                <a:effectLst/>
+                <a:latin typeface="Calibri" panose="020F0502020204030204" pitchFamily="34" charset="0"/>
+                <a:cs typeface="Calibri" panose="020F0502020204030204" pitchFamily="34" charset="0"/>
+              </a:rPr>
+              <a:t>/</a:t>
+            </a:r>
+            <a:r>
+              <a:rPr lang="en-US" b="0" u="sng" dirty="0" err="1">
+                <a:solidFill>
+                  <a:schemeClr val="bg1"/>
+                </a:solidFill>
+                <a:effectLst/>
+                <a:latin typeface="Calibri" panose="020F0502020204030204" pitchFamily="34" charset="0"/>
+                <a:cs typeface="Calibri" panose="020F0502020204030204" pitchFamily="34" charset="0"/>
+              </a:rPr>
+              <a:t>seehuhn</a:t>
+            </a:r>
+            <a:r>
+              <a:rPr lang="en-US" b="0" u="sng" dirty="0">
+                <a:solidFill>
+                  <a:schemeClr val="bg1"/>
+                </a:solidFill>
+                <a:effectLst/>
+                <a:latin typeface="Calibri" panose="020F0502020204030204" pitchFamily="34" charset="0"/>
+                <a:cs typeface="Calibri" panose="020F0502020204030204" pitchFamily="34" charset="0"/>
+              </a:rPr>
+              <a:t>/</a:t>
+            </a:r>
+            <a:r>
+              <a:rPr lang="en-US" b="0" u="sng" dirty="0" err="1">
+                <a:solidFill>
+                  <a:schemeClr val="bg1"/>
+                </a:solidFill>
+                <a:effectLst/>
+                <a:latin typeface="Calibri" panose="020F0502020204030204" pitchFamily="34" charset="0"/>
+                <a:cs typeface="Calibri" panose="020F0502020204030204" pitchFamily="34" charset="0"/>
+              </a:rPr>
+              <a:t>dieharder</a:t>
+            </a:r>
+            <a:endParaRPr lang="en-US" b="0" u="sng" dirty="0">
+              <a:solidFill>
+                <a:schemeClr val="bg1"/>
+              </a:solidFill>
+              <a:effectLst/>
+              <a:latin typeface="Calibri" panose="020F0502020204030204" pitchFamily="34" charset="0"/>
+              <a:cs typeface="Calibri" panose="020F0502020204030204" pitchFamily="34" charset="0"/>
+            </a:endParaRPr>
+          </a:p>
+          <a:p>
+            <a:pPr>
+              <a:lnSpc>
+                <a:spcPts val="1350"/>
+              </a:lnSpc>
+              <a:buNone/>
+            </a:pPr>
+            <a:br>
+              <a:rPr lang="en-US" b="0" dirty="0">
+                <a:solidFill>
+                  <a:schemeClr val="bg1"/>
+                </a:solidFill>
+                <a:effectLst/>
+                <a:latin typeface="Calibri" panose="020F0502020204030204" pitchFamily="34" charset="0"/>
+                <a:cs typeface="Calibri" panose="020F0502020204030204" pitchFamily="34" charset="0"/>
+              </a:rPr>
+            </a:br>
+            <a:endParaRPr lang="en-US" b="0" dirty="0">
+              <a:solidFill>
+                <a:schemeClr val="bg1"/>
+              </a:solidFill>
+              <a:effectLst/>
+              <a:latin typeface="Calibri" panose="020F0502020204030204" pitchFamily="34" charset="0"/>
+              <a:cs typeface="Calibri" panose="020F0502020204030204" pitchFamily="34" charset="0"/>
+            </a:endParaRPr>
+          </a:p>
+          <a:p>
+            <a:pPr>
+              <a:lnSpc>
+                <a:spcPts val="1350"/>
+              </a:lnSpc>
+              <a:buNone/>
+            </a:pPr>
+            <a:r>
+              <a:rPr lang="en-US" sz="2400" b="1" dirty="0">
+                <a:solidFill>
+                  <a:schemeClr val="bg1"/>
+                </a:solidFill>
+                <a:effectLst/>
+                <a:latin typeface="Calibri" panose="020F0502020204030204" pitchFamily="34" charset="0"/>
+                <a:cs typeface="Calibri" panose="020F0502020204030204" pitchFamily="34" charset="0"/>
+              </a:rPr>
+              <a:t>RANDOM.ORG offers true random numbers to anyone on the Internet</a:t>
+            </a:r>
+            <a:endParaRPr lang="en-US" sz="2400" b="0" dirty="0">
+              <a:solidFill>
+                <a:schemeClr val="bg1"/>
+              </a:solidFill>
+              <a:effectLst/>
+              <a:latin typeface="Calibri" panose="020F0502020204030204" pitchFamily="34" charset="0"/>
+              <a:cs typeface="Calibri" panose="020F0502020204030204" pitchFamily="34" charset="0"/>
+            </a:endParaRPr>
+          </a:p>
+          <a:p>
+            <a:pPr>
+              <a:lnSpc>
+                <a:spcPts val="1350"/>
+              </a:lnSpc>
+              <a:buNone/>
+            </a:pPr>
+            <a:r>
+              <a:rPr lang="en-US" b="0" u="sng" dirty="0">
+                <a:solidFill>
+                  <a:schemeClr val="bg1"/>
+                </a:solidFill>
+                <a:effectLst/>
+                <a:latin typeface="Calibri" panose="020F0502020204030204" pitchFamily="34" charset="0"/>
+                <a:cs typeface="Calibri" panose="020F0502020204030204" pitchFamily="34" charset="0"/>
+              </a:rPr>
+              <a:t>https://</a:t>
+            </a:r>
+            <a:r>
+              <a:rPr lang="en-US" b="0" u="sng" dirty="0" err="1">
+                <a:solidFill>
+                  <a:schemeClr val="bg1"/>
+                </a:solidFill>
+                <a:effectLst/>
+                <a:latin typeface="Calibri" panose="020F0502020204030204" pitchFamily="34" charset="0"/>
+                <a:cs typeface="Calibri" panose="020F0502020204030204" pitchFamily="34" charset="0"/>
+              </a:rPr>
+              <a:t>www.random.org</a:t>
+            </a:r>
+            <a:r>
+              <a:rPr lang="en-US" b="0" u="sng" dirty="0">
+                <a:solidFill>
+                  <a:schemeClr val="bg1"/>
+                </a:solidFill>
+                <a:effectLst/>
+                <a:latin typeface="Calibri" panose="020F0502020204030204" pitchFamily="34" charset="0"/>
+                <a:cs typeface="Calibri" panose="020F0502020204030204" pitchFamily="34" charset="0"/>
+              </a:rPr>
+              <a:t>/</a:t>
+            </a:r>
+          </a:p>
+          <a:p>
+            <a:pPr>
+              <a:lnSpc>
+                <a:spcPts val="1350"/>
+              </a:lnSpc>
+              <a:buNone/>
+            </a:pPr>
+            <a:br>
+              <a:rPr lang="en-US" b="0" dirty="0">
+                <a:solidFill>
+                  <a:schemeClr val="bg1"/>
+                </a:solidFill>
+                <a:effectLst/>
+                <a:latin typeface="Calibri" panose="020F0502020204030204" pitchFamily="34" charset="0"/>
+                <a:cs typeface="Calibri" panose="020F0502020204030204" pitchFamily="34" charset="0"/>
+              </a:rPr>
+            </a:br>
+            <a:endParaRPr lang="en-US" b="0" dirty="0">
+              <a:solidFill>
+                <a:schemeClr val="bg1"/>
+              </a:solidFill>
+              <a:effectLst/>
+              <a:latin typeface="Calibri" panose="020F0502020204030204" pitchFamily="34" charset="0"/>
+              <a:cs typeface="Calibri" panose="020F0502020204030204" pitchFamily="34" charset="0"/>
+            </a:endParaRPr>
+          </a:p>
+          <a:p>
+            <a:pPr>
+              <a:lnSpc>
+                <a:spcPts val="1350"/>
+              </a:lnSpc>
+              <a:buNone/>
+            </a:pPr>
+            <a:r>
+              <a:rPr lang="en-US" sz="2800" b="1" dirty="0">
+                <a:solidFill>
+                  <a:schemeClr val="bg1"/>
+                </a:solidFill>
+                <a:effectLst/>
+                <a:latin typeface="Calibri" panose="020F0502020204030204" pitchFamily="34" charset="0"/>
+                <a:cs typeface="Calibri" panose="020F0502020204030204" pitchFamily="34" charset="0"/>
+              </a:rPr>
+              <a:t>DIY - Build your own TRNG</a:t>
+            </a:r>
+            <a:endParaRPr lang="en-US" sz="2800" b="0" dirty="0">
+              <a:solidFill>
+                <a:schemeClr val="bg1"/>
+              </a:solidFill>
+              <a:effectLst/>
+              <a:latin typeface="Calibri" panose="020F0502020204030204" pitchFamily="34" charset="0"/>
+              <a:cs typeface="Calibri" panose="020F0502020204030204" pitchFamily="34" charset="0"/>
+            </a:endParaRPr>
+          </a:p>
+          <a:p>
+            <a:pPr>
+              <a:lnSpc>
+                <a:spcPts val="1350"/>
+              </a:lnSpc>
+              <a:buNone/>
+            </a:pPr>
+            <a:r>
+              <a:rPr lang="en-US" b="0" u="sng" dirty="0">
+                <a:solidFill>
+                  <a:schemeClr val="bg1"/>
+                </a:solidFill>
+                <a:effectLst/>
+                <a:latin typeface="Calibri" panose="020F0502020204030204" pitchFamily="34" charset="0"/>
+                <a:cs typeface="Calibri" panose="020F0502020204030204" pitchFamily="34" charset="0"/>
+              </a:rPr>
+              <a:t>http://</a:t>
+            </a:r>
+            <a:r>
+              <a:rPr lang="en-US" b="0" u="sng" dirty="0" err="1">
+                <a:solidFill>
+                  <a:schemeClr val="bg1"/>
+                </a:solidFill>
+                <a:effectLst/>
+                <a:latin typeface="Calibri" panose="020F0502020204030204" pitchFamily="34" charset="0"/>
+                <a:cs typeface="Calibri" panose="020F0502020204030204" pitchFamily="34" charset="0"/>
+              </a:rPr>
+              <a:t>www.reallyreallyrandom.com</a:t>
+            </a:r>
+            <a:r>
+              <a:rPr lang="en-US" b="0" u="sng" dirty="0">
+                <a:solidFill>
+                  <a:schemeClr val="bg1"/>
+                </a:solidFill>
+                <a:effectLst/>
+                <a:latin typeface="Calibri" panose="020F0502020204030204" pitchFamily="34" charset="0"/>
+                <a:cs typeface="Calibri" panose="020F0502020204030204" pitchFamily="34" charset="0"/>
+              </a:rPr>
+              <a:t>/</a:t>
+            </a:r>
+            <a:r>
+              <a:rPr lang="en-US" b="0" u="sng" dirty="0" err="1">
+                <a:solidFill>
+                  <a:schemeClr val="bg1"/>
+                </a:solidFill>
+                <a:effectLst/>
+                <a:latin typeface="Calibri" panose="020F0502020204030204" pitchFamily="34" charset="0"/>
+                <a:cs typeface="Calibri" panose="020F0502020204030204" pitchFamily="34" charset="0"/>
+              </a:rPr>
+              <a:t>index.html</a:t>
+            </a:r>
+            <a:endParaRPr lang="en-US" b="0" u="sng" dirty="0">
+              <a:solidFill>
+                <a:schemeClr val="bg1"/>
+              </a:solidFill>
+              <a:effectLst/>
+              <a:latin typeface="Calibri" panose="020F0502020204030204" pitchFamily="34" charset="0"/>
+              <a:cs typeface="Calibri" panose="020F0502020204030204" pitchFamily="34" charset="0"/>
+            </a:endParaRPr>
+          </a:p>
+          <a:p>
+            <a:pPr>
+              <a:lnSpc>
+                <a:spcPts val="1350"/>
+              </a:lnSpc>
+              <a:buNone/>
+            </a:pPr>
+            <a:br>
+              <a:rPr lang="en-US" b="0" dirty="0">
+                <a:solidFill>
+                  <a:schemeClr val="bg1"/>
+                </a:solidFill>
+                <a:effectLst/>
+                <a:latin typeface="Calibri" panose="020F0502020204030204" pitchFamily="34" charset="0"/>
+                <a:cs typeface="Calibri" panose="020F0502020204030204" pitchFamily="34" charset="0"/>
+              </a:rPr>
+            </a:br>
+            <a:endParaRPr lang="en-US" b="0" dirty="0">
+              <a:solidFill>
+                <a:schemeClr val="bg1"/>
+              </a:solidFill>
+              <a:effectLst/>
+              <a:latin typeface="Calibri" panose="020F0502020204030204" pitchFamily="34" charset="0"/>
+              <a:cs typeface="Calibri" panose="020F0502020204030204" pitchFamily="34" charset="0"/>
+            </a:endParaRPr>
+          </a:p>
+        </p:txBody>
+      </p:sp>
     </p:spTree>
   </p:cSld>
   <p:clrMapOvr>

</xml_diff>

<commit_message>
Update randomness testing presentation and QRNG README
</commit_message>
<xml_diff>
--- a/Presentations/4.True Randomness Testing & Random Number Generators.pptx
+++ b/Presentations/4.True Randomness Testing & Random Number Generators.pptx
@@ -11917,8 +11917,8 @@
         </p:nvSpPr>
         <p:spPr>
           <a:xfrm>
-            <a:off x="609583" y="953482"/>
-            <a:ext cx="11253865" cy="4237699"/>
+            <a:off x="609583" y="858482"/>
+            <a:ext cx="11253865" cy="6398931"/>
           </a:xfrm>
           <a:prstGeom prst="rect">
             <a:avLst/>
@@ -11937,7 +11937,145 @@
               </a:lnSpc>
               <a:buNone/>
             </a:pPr>
-            <a:endParaRPr lang="en-US" b="0" dirty="0">
+            <a:r>
+              <a:rPr lang="en-US" sz="2000" b="1" dirty="0">
+                <a:solidFill>
+                  <a:schemeClr val="bg1"/>
+                </a:solidFill>
+                <a:latin typeface="Calibri" panose="020F0502020204030204" pitchFamily="34" charset="0"/>
+                <a:cs typeface="Calibri" panose="020F0502020204030204" pitchFamily="34" charset="0"/>
+              </a:rPr>
+              <a:t>- Entropy Test (</a:t>
+            </a:r>
+            <a:r>
+              <a:rPr lang="en-US" sz="2000" b="1" dirty="0" err="1">
+                <a:solidFill>
+                  <a:schemeClr val="bg1"/>
+                </a:solidFill>
+                <a:latin typeface="Calibri" panose="020F0502020204030204" pitchFamily="34" charset="0"/>
+                <a:cs typeface="Calibri" panose="020F0502020204030204" pitchFamily="34" charset="0"/>
+              </a:rPr>
+              <a:t>ent</a:t>
+            </a:r>
+            <a:r>
+              <a:rPr lang="en-US" sz="2000" b="1" dirty="0">
+                <a:solidFill>
+                  <a:schemeClr val="bg1"/>
+                </a:solidFill>
+                <a:latin typeface="Calibri" panose="020F0502020204030204" pitchFamily="34" charset="0"/>
+                <a:cs typeface="Calibri" panose="020F0502020204030204" pitchFamily="34" charset="0"/>
+              </a:rPr>
+              <a:t>) </a:t>
+            </a:r>
+          </a:p>
+          <a:p>
+            <a:pPr>
+              <a:lnSpc>
+                <a:spcPts val="1350"/>
+              </a:lnSpc>
+              <a:buNone/>
+            </a:pPr>
+            <a:endParaRPr lang="en-US" sz="2000" dirty="0">
+              <a:solidFill>
+                <a:schemeClr val="bg1"/>
+              </a:solidFill>
+              <a:latin typeface="Calibri" panose="020F0502020204030204" pitchFamily="34" charset="0"/>
+              <a:cs typeface="Calibri" panose="020F0502020204030204" pitchFamily="34" charset="0"/>
+            </a:endParaRPr>
+          </a:p>
+          <a:p>
+            <a:pPr lvl="1">
+              <a:lnSpc>
+                <a:spcPts val="1350"/>
+              </a:lnSpc>
+            </a:pPr>
+            <a:r>
+              <a:rPr lang="en-US" u="sng" dirty="0">
+                <a:solidFill>
+                  <a:schemeClr val="accent1"/>
+                </a:solidFill>
+                <a:latin typeface="Calibri" panose="020F0502020204030204" pitchFamily="34" charset="0"/>
+                <a:cs typeface="Calibri" panose="020F0502020204030204" pitchFamily="34" charset="0"/>
+              </a:rPr>
+              <a:t>https://</a:t>
+            </a:r>
+            <a:r>
+              <a:rPr lang="en-US" u="sng" dirty="0" err="1">
+                <a:solidFill>
+                  <a:schemeClr val="accent1"/>
+                </a:solidFill>
+                <a:latin typeface="Calibri" panose="020F0502020204030204" pitchFamily="34" charset="0"/>
+                <a:cs typeface="Calibri" panose="020F0502020204030204" pitchFamily="34" charset="0"/>
+              </a:rPr>
+              <a:t>www.fourmilab.ch</a:t>
+            </a:r>
+            <a:r>
+              <a:rPr lang="en-US" u="sng" dirty="0">
+                <a:solidFill>
+                  <a:schemeClr val="accent1"/>
+                </a:solidFill>
+                <a:latin typeface="Calibri" panose="020F0502020204030204" pitchFamily="34" charset="0"/>
+                <a:cs typeface="Calibri" panose="020F0502020204030204" pitchFamily="34" charset="0"/>
+              </a:rPr>
+              <a:t>/random/</a:t>
+            </a:r>
+          </a:p>
+          <a:p>
+            <a:pPr lvl="1">
+              <a:lnSpc>
+                <a:spcPts val="1350"/>
+              </a:lnSpc>
+            </a:pPr>
+            <a:endParaRPr lang="en-US" dirty="0">
+              <a:solidFill>
+                <a:schemeClr val="bg1"/>
+              </a:solidFill>
+              <a:latin typeface="Calibri" panose="020F0502020204030204" pitchFamily="34" charset="0"/>
+              <a:cs typeface="Calibri" panose="020F0502020204030204" pitchFamily="34" charset="0"/>
+            </a:endParaRPr>
+          </a:p>
+          <a:p>
+            <a:pPr lvl="1">
+              <a:lnSpc>
+                <a:spcPts val="1350"/>
+              </a:lnSpc>
+            </a:pPr>
+            <a:r>
+              <a:rPr lang="en-US" dirty="0">
+                <a:solidFill>
+                  <a:schemeClr val="bg1"/>
+                </a:solidFill>
+                <a:latin typeface="Calibri" panose="020F0502020204030204" pitchFamily="34" charset="0"/>
+                <a:cs typeface="Calibri" panose="020F0502020204030204" pitchFamily="34" charset="0"/>
+              </a:rPr>
+              <a:t>Usage: dd if=/dev/random  count=8192 | </a:t>
+            </a:r>
+            <a:r>
+              <a:rPr lang="en-US" dirty="0" err="1">
+                <a:solidFill>
+                  <a:schemeClr val="bg1"/>
+                </a:solidFill>
+                <a:latin typeface="Calibri" panose="020F0502020204030204" pitchFamily="34" charset="0"/>
+                <a:cs typeface="Calibri" panose="020F0502020204030204" pitchFamily="34" charset="0"/>
+              </a:rPr>
+              <a:t>ent</a:t>
+            </a:r>
+            <a:endParaRPr lang="en-US" dirty="0">
+              <a:solidFill>
+                <a:schemeClr val="bg1"/>
+              </a:solidFill>
+              <a:latin typeface="Calibri" panose="020F0502020204030204" pitchFamily="34" charset="0"/>
+              <a:cs typeface="Calibri" panose="020F0502020204030204" pitchFamily="34" charset="0"/>
+            </a:endParaRPr>
+          </a:p>
+          <a:p>
+            <a:pPr>
+              <a:lnSpc>
+                <a:spcPts val="1350"/>
+              </a:lnSpc>
+              <a:buNone/>
+            </a:pPr>
+            <a:endParaRPr lang="en-US" sz="2000" b="0" dirty="0">
               <a:solidFill>
                 <a:schemeClr val="bg1"/>
               </a:solidFill>
@@ -11954,7 +12092,7 @@
               <a:buNone/>
             </a:pPr>
             <a:br>
-              <a:rPr lang="en-US" b="0" dirty="0">
+              <a:rPr lang="en-US" sz="2000" b="0" dirty="0">
                 <a:solidFill>
                   <a:schemeClr val="bg1"/>
                 </a:solidFill>
@@ -11963,7 +12101,7 @@
                 <a:cs typeface="Calibri" panose="020F0502020204030204" pitchFamily="34" charset="0"/>
               </a:rPr>
             </a:br>
-            <a:endParaRPr lang="en-US" b="0" dirty="0">
+            <a:endParaRPr lang="en-US" sz="2000" b="0" dirty="0">
               <a:solidFill>
                 <a:schemeClr val="bg1"/>
               </a:solidFill>
@@ -11980,7 +12118,7 @@
               <a:buNone/>
             </a:pPr>
             <a:r>
-              <a:rPr lang="en-US" sz="2800" b="1" dirty="0">
+              <a:rPr lang="en-US" sz="2000" b="1" dirty="0">
                 <a:solidFill>
                   <a:schemeClr val="bg1"/>
                 </a:solidFill>
@@ -11988,20 +12126,9 @@
                 <a:latin typeface="Calibri" panose="020F0502020204030204" pitchFamily="34" charset="0"/>
                 <a:cs typeface="Calibri" panose="020F0502020204030204" pitchFamily="34" charset="0"/>
               </a:rPr>
-              <a:t>NIST-Statistical-Test-Suite</a:t>
-            </a:r>
-            <a:r>
-              <a:rPr lang="en-US" b="1" dirty="0">
-                <a:solidFill>
-                  <a:schemeClr val="bg1"/>
-                </a:solidFill>
-                <a:effectLst/>
-                <a:latin typeface="Calibri" panose="020F0502020204030204" pitchFamily="34" charset="0"/>
-                <a:cs typeface="Calibri" panose="020F0502020204030204" pitchFamily="34" charset="0"/>
-              </a:rPr>
-              <a:t> </a:t>
-            </a:r>
-            <a:endParaRPr lang="en-US" b="0" dirty="0">
+              <a:t>- NIST-Statistical-Test-Suite </a:t>
+            </a:r>
+            <a:endParaRPr lang="en-US" sz="2000" b="0" dirty="0">
               <a:solidFill>
                 <a:schemeClr val="bg1"/>
               </a:solidFill>
@@ -12017,10 +12144,25 @@
               </a:lnSpc>
               <a:buNone/>
             </a:pPr>
+            <a:endParaRPr lang="en-US" sz="2000" b="0" u="sng" dirty="0">
+              <a:solidFill>
+                <a:schemeClr val="accent1"/>
+              </a:solidFill>
+              <a:effectLst/>
+              <a:latin typeface="Calibri" panose="020F0502020204030204" pitchFamily="34" charset="0"/>
+              <a:cs typeface="Calibri" panose="020F0502020204030204" pitchFamily="34" charset="0"/>
+            </a:endParaRPr>
+          </a:p>
+          <a:p>
+            <a:pPr lvl="1">
+              <a:lnSpc>
+                <a:spcPts val="1350"/>
+              </a:lnSpc>
+            </a:pPr>
             <a:r>
               <a:rPr lang="en-US" b="0" u="sng" dirty="0">
                 <a:solidFill>
-                  <a:schemeClr val="bg1"/>
+                  <a:schemeClr val="accent1"/>
                 </a:solidFill>
                 <a:effectLst/>
                 <a:latin typeface="Calibri" panose="020F0502020204030204" pitchFamily="34" charset="0"/>
@@ -12031,7 +12173,7 @@
             <a:r>
               <a:rPr lang="en-US" b="0" u="sng" dirty="0" err="1">
                 <a:solidFill>
-                  <a:schemeClr val="bg1"/>
+                  <a:schemeClr val="accent1"/>
                 </a:solidFill>
                 <a:effectLst/>
                 <a:latin typeface="Calibri" panose="020F0502020204030204" pitchFamily="34" charset="0"/>
@@ -12042,13 +12184,98 @@
             <a:r>
               <a:rPr lang="en-US" b="0" u="sng" dirty="0">
                 <a:solidFill>
-                  <a:schemeClr val="bg1"/>
+                  <a:schemeClr val="accent1"/>
                 </a:solidFill>
                 <a:effectLst/>
                 <a:latin typeface="Calibri" panose="020F0502020204030204" pitchFamily="34" charset="0"/>
                 <a:cs typeface="Calibri" panose="020F0502020204030204" pitchFamily="34" charset="0"/>
               </a:rPr>
               <a:t>/Projects/random-bit-generation/Documentation-and-Software/Guide-to-the-Statistical-Tests</a:t>
+            </a:r>
+            <a:endParaRPr lang="en-US" b="0" dirty="0">
+              <a:solidFill>
+                <a:schemeClr val="accent1"/>
+              </a:solidFill>
+              <a:effectLst/>
+              <a:latin typeface="Calibri" panose="020F0502020204030204" pitchFamily="34" charset="0"/>
+              <a:cs typeface="Calibri" panose="020F0502020204030204" pitchFamily="34" charset="0"/>
+            </a:endParaRPr>
+          </a:p>
+          <a:p>
+            <a:pPr lvl="1">
+              <a:lnSpc>
+                <a:spcPts val="1350"/>
+              </a:lnSpc>
+            </a:pPr>
+            <a:endParaRPr lang="en-US" b="0" u="sng" dirty="0">
+              <a:solidFill>
+                <a:schemeClr val="accent1"/>
+              </a:solidFill>
+              <a:effectLst/>
+              <a:latin typeface="Calibri" panose="020F0502020204030204" pitchFamily="34" charset="0"/>
+              <a:cs typeface="Calibri" panose="020F0502020204030204" pitchFamily="34" charset="0"/>
+            </a:endParaRPr>
+          </a:p>
+          <a:p>
+            <a:pPr lvl="1">
+              <a:lnSpc>
+                <a:spcPts val="1350"/>
+              </a:lnSpc>
+            </a:pPr>
+            <a:r>
+              <a:rPr lang="en-US" b="0" u="sng" dirty="0">
+                <a:solidFill>
+                  <a:schemeClr val="accent1"/>
+                </a:solidFill>
+                <a:effectLst/>
+                <a:latin typeface="Calibri" panose="020F0502020204030204" pitchFamily="34" charset="0"/>
+                <a:cs typeface="Calibri" panose="020F0502020204030204" pitchFamily="34" charset="0"/>
+              </a:rPr>
+              <a:t>https://</a:t>
+            </a:r>
+            <a:r>
+              <a:rPr lang="en-US" b="0" u="sng" dirty="0" err="1">
+                <a:solidFill>
+                  <a:schemeClr val="accent1"/>
+                </a:solidFill>
+                <a:effectLst/>
+                <a:latin typeface="Calibri" panose="020F0502020204030204" pitchFamily="34" charset="0"/>
+                <a:cs typeface="Calibri" panose="020F0502020204030204" pitchFamily="34" charset="0"/>
+              </a:rPr>
+              <a:t>github.com</a:t>
+            </a:r>
+            <a:r>
+              <a:rPr lang="en-US" b="0" u="sng" dirty="0">
+                <a:solidFill>
+                  <a:schemeClr val="accent1"/>
+                </a:solidFill>
+                <a:effectLst/>
+                <a:latin typeface="Calibri" panose="020F0502020204030204" pitchFamily="34" charset="0"/>
+                <a:cs typeface="Calibri" panose="020F0502020204030204" pitchFamily="34" charset="0"/>
+              </a:rPr>
+              <a:t>/</a:t>
+            </a:r>
+            <a:r>
+              <a:rPr lang="en-US" b="0" u="sng" dirty="0" err="1">
+                <a:solidFill>
+                  <a:schemeClr val="accent1"/>
+                </a:solidFill>
+                <a:effectLst/>
+                <a:latin typeface="Calibri" panose="020F0502020204030204" pitchFamily="34" charset="0"/>
+                <a:cs typeface="Calibri" panose="020F0502020204030204" pitchFamily="34" charset="0"/>
+              </a:rPr>
+              <a:t>terrillmoore</a:t>
+            </a:r>
+            <a:r>
+              <a:rPr lang="en-US" b="0" u="sng" dirty="0">
+                <a:solidFill>
+                  <a:schemeClr val="accent1"/>
+                </a:solidFill>
+                <a:effectLst/>
+                <a:latin typeface="Calibri" panose="020F0502020204030204" pitchFamily="34" charset="0"/>
+                <a:cs typeface="Calibri" panose="020F0502020204030204" pitchFamily="34" charset="0"/>
+              </a:rPr>
+              <a:t>/NIST-Statistical-Test-Suite</a:t>
             </a:r>
           </a:p>
           <a:p>
@@ -12058,7 +12285,17 @@
               </a:lnSpc>
               <a:buNone/>
             </a:pPr>
-            <a:endParaRPr lang="en-US" b="0" dirty="0">
+            <a:br>
+              <a:rPr lang="en-US" sz="2000" b="0" dirty="0">
+                <a:solidFill>
+                  <a:schemeClr val="bg1"/>
+                </a:solidFill>
+                <a:effectLst/>
+                <a:latin typeface="Calibri" panose="020F0502020204030204" pitchFamily="34" charset="0"/>
+                <a:cs typeface="Calibri" panose="020F0502020204030204" pitchFamily="34" charset="0"/>
+              </a:rPr>
+            </a:br>
+            <a:endParaRPr lang="en-US" sz="2000" b="0" dirty="0">
               <a:solidFill>
                 <a:schemeClr val="bg1"/>
               </a:solidFill>
@@ -12075,7 +12312,7 @@
               <a:buNone/>
             </a:pPr>
             <a:r>
-              <a:rPr lang="en-US" b="0" u="sng" dirty="0">
+              <a:rPr lang="en-US" sz="2000" b="1" dirty="0">
                 <a:solidFill>
                   <a:schemeClr val="bg1"/>
                 </a:solidFill>
@@ -12083,10 +12320,10 @@
                 <a:latin typeface="Calibri" panose="020F0502020204030204" pitchFamily="34" charset="0"/>
                 <a:cs typeface="Calibri" panose="020F0502020204030204" pitchFamily="34" charset="0"/>
               </a:rPr>
-              <a:t>https://</a:t>
-            </a:r>
-            <a:r>
-              <a:rPr lang="en-US" b="0" u="sng" dirty="0" err="1">
+              <a:t>- </a:t>
+            </a:r>
+            <a:r>
+              <a:rPr lang="en-US" sz="2000" b="1" dirty="0" err="1">
                 <a:solidFill>
                   <a:schemeClr val="bg1"/>
                 </a:solidFill>
@@ -12094,10 +12331,10 @@
                 <a:latin typeface="Calibri" panose="020F0502020204030204" pitchFamily="34" charset="0"/>
                 <a:cs typeface="Calibri" panose="020F0502020204030204" pitchFamily="34" charset="0"/>
               </a:rPr>
-              <a:t>github.com</a:t>
-            </a:r>
-            <a:r>
-              <a:rPr lang="en-US" b="0" u="sng" dirty="0">
+              <a:t>Dieharder</a:t>
+            </a:r>
+            <a:r>
+              <a:rPr lang="en-US" sz="2000" b="1" dirty="0">
                 <a:solidFill>
                   <a:schemeClr val="bg1"/>
                 </a:solidFill>
@@ -12105,29 +12342,263 @@
                 <a:latin typeface="Calibri" panose="020F0502020204030204" pitchFamily="34" charset="0"/>
                 <a:cs typeface="Calibri" panose="020F0502020204030204" pitchFamily="34" charset="0"/>
               </a:rPr>
-              <a:t>/</a:t>
-            </a:r>
-            <a:r>
-              <a:rPr lang="en-US" b="0" u="sng" dirty="0" err="1">
-                <a:solidFill>
-                  <a:schemeClr val="bg1"/>
+              <a:t> - Robert G. Brown</a:t>
+            </a:r>
+            <a:endParaRPr lang="en-US" sz="2000" b="0" dirty="0">
+              <a:solidFill>
+                <a:schemeClr val="bg1"/>
+              </a:solidFill>
+              <a:effectLst/>
+              <a:latin typeface="Calibri" panose="020F0502020204030204" pitchFamily="34" charset="0"/>
+              <a:cs typeface="Calibri" panose="020F0502020204030204" pitchFamily="34" charset="0"/>
+            </a:endParaRPr>
+          </a:p>
+          <a:p>
+            <a:pPr>
+              <a:lnSpc>
+                <a:spcPts val="1350"/>
+              </a:lnSpc>
+              <a:buNone/>
+            </a:pPr>
+            <a:endParaRPr lang="en-US" sz="2000" b="0" u="sng" dirty="0">
+              <a:solidFill>
+                <a:schemeClr val="accent1"/>
+              </a:solidFill>
+              <a:effectLst/>
+              <a:latin typeface="Calibri" panose="020F0502020204030204" pitchFamily="34" charset="0"/>
+              <a:cs typeface="Calibri" panose="020F0502020204030204" pitchFamily="34" charset="0"/>
+            </a:endParaRPr>
+          </a:p>
+          <a:p>
+            <a:pPr lvl="1">
+              <a:lnSpc>
+                <a:spcPts val="1350"/>
+              </a:lnSpc>
+            </a:pPr>
+            <a:r>
+              <a:rPr lang="en-US" b="0" u="sng" dirty="0">
+                <a:solidFill>
+                  <a:schemeClr val="accent1"/>
                 </a:solidFill>
                 <a:effectLst/>
                 <a:latin typeface="Calibri" panose="020F0502020204030204" pitchFamily="34" charset="0"/>
                 <a:cs typeface="Calibri" panose="020F0502020204030204" pitchFamily="34" charset="0"/>
               </a:rPr>
-              <a:t>terrillmoore</a:t>
-            </a:r>
-            <a:r>
-              <a:rPr lang="en-US" b="0" u="sng" dirty="0">
-                <a:solidFill>
-                  <a:schemeClr val="bg1"/>
+              <a:t>https://</a:t>
+            </a:r>
+            <a:r>
+              <a:rPr lang="en-US" b="0" u="sng" dirty="0" err="1">
+                <a:solidFill>
+                  <a:schemeClr val="accent1"/>
                 </a:solidFill>
                 <a:effectLst/>
                 <a:latin typeface="Calibri" panose="020F0502020204030204" pitchFamily="34" charset="0"/>
                 <a:cs typeface="Calibri" panose="020F0502020204030204" pitchFamily="34" charset="0"/>
               </a:rPr>
-              <a:t>/NIST-Statistical-Test-Suite</a:t>
+              <a:t>webhome.phy.duke.edu</a:t>
+            </a:r>
+            <a:r>
+              <a:rPr lang="en-US" b="0" u="sng" dirty="0">
+                <a:solidFill>
+                  <a:schemeClr val="accent1"/>
+                </a:solidFill>
+                <a:effectLst/>
+                <a:latin typeface="Calibri" panose="020F0502020204030204" pitchFamily="34" charset="0"/>
+                <a:cs typeface="Calibri" panose="020F0502020204030204" pitchFamily="34" charset="0"/>
+              </a:rPr>
+              <a:t>/~</a:t>
+            </a:r>
+            <a:r>
+              <a:rPr lang="en-US" b="0" u="sng" dirty="0" err="1">
+                <a:solidFill>
+                  <a:schemeClr val="accent1"/>
+                </a:solidFill>
+                <a:effectLst/>
+                <a:latin typeface="Calibri" panose="020F0502020204030204" pitchFamily="34" charset="0"/>
+                <a:cs typeface="Calibri" panose="020F0502020204030204" pitchFamily="34" charset="0"/>
+              </a:rPr>
+              <a:t>rgb</a:t>
+            </a:r>
+            <a:r>
+              <a:rPr lang="en-US" b="0" u="sng" dirty="0">
+                <a:solidFill>
+                  <a:schemeClr val="accent1"/>
+                </a:solidFill>
+                <a:effectLst/>
+                <a:latin typeface="Calibri" panose="020F0502020204030204" pitchFamily="34" charset="0"/>
+                <a:cs typeface="Calibri" panose="020F0502020204030204" pitchFamily="34" charset="0"/>
+              </a:rPr>
+              <a:t>/General/</a:t>
+            </a:r>
+            <a:r>
+              <a:rPr lang="en-US" b="0" u="sng" dirty="0" err="1">
+                <a:solidFill>
+                  <a:schemeClr val="accent1"/>
+                </a:solidFill>
+                <a:effectLst/>
+                <a:latin typeface="Calibri" panose="020F0502020204030204" pitchFamily="34" charset="0"/>
+                <a:cs typeface="Calibri" panose="020F0502020204030204" pitchFamily="34" charset="0"/>
+              </a:rPr>
+              <a:t>dieharder.php</a:t>
+            </a:r>
+            <a:endParaRPr lang="en-US" b="0" u="sng" dirty="0">
+              <a:solidFill>
+                <a:schemeClr val="accent1"/>
+              </a:solidFill>
+              <a:effectLst/>
+              <a:latin typeface="Calibri" panose="020F0502020204030204" pitchFamily="34" charset="0"/>
+              <a:cs typeface="Calibri" panose="020F0502020204030204" pitchFamily="34" charset="0"/>
+            </a:endParaRPr>
+          </a:p>
+          <a:p>
+            <a:pPr lvl="1">
+              <a:lnSpc>
+                <a:spcPts val="1350"/>
+              </a:lnSpc>
+            </a:pPr>
+            <a:endParaRPr lang="en-US" b="0" u="sng" dirty="0">
+              <a:solidFill>
+                <a:schemeClr val="accent1"/>
+              </a:solidFill>
+              <a:effectLst/>
+              <a:latin typeface="Calibri" panose="020F0502020204030204" pitchFamily="34" charset="0"/>
+              <a:cs typeface="Calibri" panose="020F0502020204030204" pitchFamily="34" charset="0"/>
+            </a:endParaRPr>
+          </a:p>
+          <a:p>
+            <a:pPr lvl="1">
+              <a:lnSpc>
+                <a:spcPts val="1350"/>
+              </a:lnSpc>
+            </a:pPr>
+            <a:r>
+              <a:rPr lang="en-US" b="0" u="sng" dirty="0">
+                <a:solidFill>
+                  <a:schemeClr val="accent1"/>
+                </a:solidFill>
+                <a:effectLst/>
+                <a:latin typeface="Calibri" panose="020F0502020204030204" pitchFamily="34" charset="0"/>
+                <a:cs typeface="Calibri" panose="020F0502020204030204" pitchFamily="34" charset="0"/>
+              </a:rPr>
+              <a:t>https://</a:t>
+            </a:r>
+            <a:r>
+              <a:rPr lang="en-US" b="0" u="sng" dirty="0" err="1">
+                <a:solidFill>
+                  <a:schemeClr val="accent1"/>
+                </a:solidFill>
+                <a:effectLst/>
+                <a:latin typeface="Calibri" panose="020F0502020204030204" pitchFamily="34" charset="0"/>
+                <a:cs typeface="Calibri" panose="020F0502020204030204" pitchFamily="34" charset="0"/>
+              </a:rPr>
+              <a:t>github.com</a:t>
+            </a:r>
+            <a:r>
+              <a:rPr lang="en-US" b="0" u="sng" dirty="0">
+                <a:solidFill>
+                  <a:schemeClr val="accent1"/>
+                </a:solidFill>
+                <a:effectLst/>
+                <a:latin typeface="Calibri" panose="020F0502020204030204" pitchFamily="34" charset="0"/>
+                <a:cs typeface="Calibri" panose="020F0502020204030204" pitchFamily="34" charset="0"/>
+              </a:rPr>
+              <a:t>/</a:t>
+            </a:r>
+            <a:r>
+              <a:rPr lang="en-US" b="0" u="sng" dirty="0" err="1">
+                <a:solidFill>
+                  <a:schemeClr val="accent1"/>
+                </a:solidFill>
+                <a:effectLst/>
+                <a:latin typeface="Calibri" panose="020F0502020204030204" pitchFamily="34" charset="0"/>
+                <a:cs typeface="Calibri" panose="020F0502020204030204" pitchFamily="34" charset="0"/>
+              </a:rPr>
+              <a:t>seehuhn</a:t>
+            </a:r>
+            <a:r>
+              <a:rPr lang="en-US" b="0" u="sng" dirty="0">
+                <a:solidFill>
+                  <a:schemeClr val="accent1"/>
+                </a:solidFill>
+                <a:effectLst/>
+                <a:latin typeface="Calibri" panose="020F0502020204030204" pitchFamily="34" charset="0"/>
+                <a:cs typeface="Calibri" panose="020F0502020204030204" pitchFamily="34" charset="0"/>
+              </a:rPr>
+              <a:t>/</a:t>
+            </a:r>
+            <a:r>
+              <a:rPr lang="en-US" b="0" u="sng" dirty="0" err="1">
+                <a:solidFill>
+                  <a:schemeClr val="accent1"/>
+                </a:solidFill>
+                <a:effectLst/>
+                <a:latin typeface="Calibri" panose="020F0502020204030204" pitchFamily="34" charset="0"/>
+                <a:cs typeface="Calibri" panose="020F0502020204030204" pitchFamily="34" charset="0"/>
+              </a:rPr>
+              <a:t>dieharder</a:t>
+            </a:r>
+            <a:endParaRPr lang="en-US" b="0" u="sng" dirty="0">
+              <a:solidFill>
+                <a:schemeClr val="accent1"/>
+              </a:solidFill>
+              <a:effectLst/>
+              <a:latin typeface="Calibri" panose="020F0502020204030204" pitchFamily="34" charset="0"/>
+              <a:cs typeface="Calibri" panose="020F0502020204030204" pitchFamily="34" charset="0"/>
+            </a:endParaRPr>
+          </a:p>
+          <a:p>
+            <a:pPr lvl="1">
+              <a:lnSpc>
+                <a:spcPts val="1350"/>
+              </a:lnSpc>
+            </a:pPr>
+            <a:endParaRPr lang="en-US" b="0" u="sng" dirty="0">
+              <a:solidFill>
+                <a:schemeClr val="accent1"/>
+              </a:solidFill>
+              <a:effectLst/>
+              <a:latin typeface="Calibri" panose="020F0502020204030204" pitchFamily="34" charset="0"/>
+              <a:cs typeface="Calibri" panose="020F0502020204030204" pitchFamily="34" charset="0"/>
+            </a:endParaRPr>
+          </a:p>
+          <a:p>
+            <a:pPr lvl="1">
+              <a:lnSpc>
+                <a:spcPts val="1350"/>
+              </a:lnSpc>
+            </a:pPr>
+            <a:r>
+              <a:rPr lang="en-US" b="0" dirty="0">
+                <a:solidFill>
+                  <a:schemeClr val="bg1"/>
+                </a:solidFill>
+                <a:effectLst/>
+                <a:latin typeface="Calibri" panose="020F0502020204030204" pitchFamily="34" charset="0"/>
+                <a:cs typeface="Calibri" panose="020F0502020204030204" pitchFamily="34" charset="0"/>
+              </a:rPr>
+              <a:t>Usage: dd if=/dev/random  count=8192 | </a:t>
+            </a:r>
+            <a:r>
+              <a:rPr lang="en-US" b="0" dirty="0" err="1">
+                <a:solidFill>
+                  <a:schemeClr val="bg1"/>
+                </a:solidFill>
+                <a:effectLst/>
+                <a:latin typeface="Calibri" panose="020F0502020204030204" pitchFamily="34" charset="0"/>
+                <a:cs typeface="Calibri" panose="020F0502020204030204" pitchFamily="34" charset="0"/>
+              </a:rPr>
+              <a:t>dieharder</a:t>
+            </a:r>
+            <a:r>
+              <a:rPr lang="en-US" b="0" dirty="0">
+                <a:solidFill>
+                  <a:schemeClr val="bg1"/>
+                </a:solidFill>
+                <a:effectLst/>
+                <a:latin typeface="Calibri" panose="020F0502020204030204" pitchFamily="34" charset="0"/>
+                <a:cs typeface="Calibri" panose="020F0502020204030204" pitchFamily="34" charset="0"/>
+              </a:rPr>
+              <a:t> -a </a:t>
             </a:r>
           </a:p>
           <a:p>
@@ -12138,7 +12609,7 @@
               <a:buNone/>
             </a:pPr>
             <a:br>
-              <a:rPr lang="en-US" b="0" dirty="0">
+              <a:rPr lang="en-US" sz="2000" b="0" dirty="0">
                 <a:solidFill>
                   <a:schemeClr val="bg1"/>
                 </a:solidFill>
@@ -12147,7 +12618,7 @@
                 <a:cs typeface="Calibri" panose="020F0502020204030204" pitchFamily="34" charset="0"/>
               </a:rPr>
             </a:br>
-            <a:endParaRPr lang="en-US" b="0" dirty="0">
+            <a:endParaRPr lang="en-US" sz="2000" b="0" dirty="0">
               <a:solidFill>
                 <a:schemeClr val="bg1"/>
               </a:solidFill>
@@ -12164,7 +12635,7 @@
               <a:buNone/>
             </a:pPr>
             <a:r>
-              <a:rPr lang="en-US" sz="2800" b="1" dirty="0" err="1">
+              <a:rPr lang="en-US" sz="2000" b="1" dirty="0">
                 <a:solidFill>
                   <a:schemeClr val="bg1"/>
                 </a:solidFill>
@@ -12172,20 +12643,9 @@
                 <a:latin typeface="Calibri" panose="020F0502020204030204" pitchFamily="34" charset="0"/>
                 <a:cs typeface="Calibri" panose="020F0502020204030204" pitchFamily="34" charset="0"/>
               </a:rPr>
-              <a:t>dieharder</a:t>
-            </a:r>
-            <a:r>
-              <a:rPr lang="en-US" sz="2800" b="1" dirty="0">
-                <a:solidFill>
-                  <a:schemeClr val="bg1"/>
-                </a:solidFill>
-                <a:effectLst/>
-                <a:latin typeface="Calibri" panose="020F0502020204030204" pitchFamily="34" charset="0"/>
-                <a:cs typeface="Calibri" panose="020F0502020204030204" pitchFamily="34" charset="0"/>
-              </a:rPr>
-              <a:t>-Robert G. Brown</a:t>
-            </a:r>
-            <a:endParaRPr lang="en-US" sz="2800" b="0" dirty="0">
+              <a:t>- RANDOM.ORG offers true random numbers to anyone on the Internet</a:t>
+            </a:r>
+            <a:endParaRPr lang="en-US" sz="2000" b="0" dirty="0">
               <a:solidFill>
                 <a:schemeClr val="bg1"/>
               </a:solidFill>
@@ -12201,10 +12661,25 @@
               </a:lnSpc>
               <a:buNone/>
             </a:pPr>
+            <a:endParaRPr lang="en-US" sz="2000" b="0" u="sng" dirty="0">
+              <a:solidFill>
+                <a:schemeClr val="accent1"/>
+              </a:solidFill>
+              <a:effectLst/>
+              <a:latin typeface="Calibri" panose="020F0502020204030204" pitchFamily="34" charset="0"/>
+              <a:cs typeface="Calibri" panose="020F0502020204030204" pitchFamily="34" charset="0"/>
+            </a:endParaRPr>
+          </a:p>
+          <a:p>
+            <a:pPr lvl="1">
+              <a:lnSpc>
+                <a:spcPts val="1350"/>
+              </a:lnSpc>
+            </a:pPr>
             <a:r>
               <a:rPr lang="en-US" b="0" u="sng" dirty="0">
                 <a:solidFill>
-                  <a:schemeClr val="bg1"/>
+                  <a:schemeClr val="accent1"/>
                 </a:solidFill>
                 <a:effectLst/>
                 <a:latin typeface="Calibri" panose="020F0502020204030204" pitchFamily="34" charset="0"/>
@@ -12215,27 +12690,35 @@
             <a:r>
               <a:rPr lang="en-US" b="0" u="sng" dirty="0" err="1">
                 <a:solidFill>
-                  <a:schemeClr val="bg1"/>
+                  <a:schemeClr val="accent1"/>
                 </a:solidFill>
                 <a:effectLst/>
                 <a:latin typeface="Calibri" panose="020F0502020204030204" pitchFamily="34" charset="0"/>
                 <a:cs typeface="Calibri" panose="020F0502020204030204" pitchFamily="34" charset="0"/>
               </a:rPr>
-              <a:t>webhome.phy.duke.edu</a:t>
+              <a:t>www.random.org</a:t>
             </a:r>
             <a:r>
               <a:rPr lang="en-US" b="0" u="sng" dirty="0">
                 <a:solidFill>
-                  <a:schemeClr val="bg1"/>
+                  <a:schemeClr val="accent1"/>
                 </a:solidFill>
                 <a:effectLst/>
                 <a:latin typeface="Calibri" panose="020F0502020204030204" pitchFamily="34" charset="0"/>
                 <a:cs typeface="Calibri" panose="020F0502020204030204" pitchFamily="34" charset="0"/>
               </a:rPr>
-              <a:t>/~</a:t>
-            </a:r>
-            <a:r>
-              <a:rPr lang="en-US" b="0" u="sng" dirty="0" err="1">
+              <a:t>/</a:t>
+            </a:r>
+          </a:p>
+          <a:p>
+            <a:pPr>
+              <a:lnSpc>
+                <a:spcPts val="1350"/>
+              </a:lnSpc>
+              <a:buNone/>
+            </a:pPr>
+            <a:br>
+              <a:rPr lang="en-US" sz="2000" b="0" dirty="0">
                 <a:solidFill>
                   <a:schemeClr val="bg1"/>
                 </a:solidFill>
@@ -12243,31 +12726,8 @@
                 <a:latin typeface="Calibri" panose="020F0502020204030204" pitchFamily="34" charset="0"/>
                 <a:cs typeface="Calibri" panose="020F0502020204030204" pitchFamily="34" charset="0"/>
               </a:rPr>
-              <a:t>rgb</a:t>
-            </a:r>
-            <a:r>
-              <a:rPr lang="en-US" b="0" u="sng" dirty="0">
-                <a:solidFill>
-                  <a:schemeClr val="bg1"/>
-                </a:solidFill>
-                <a:effectLst/>
-                <a:latin typeface="Calibri" panose="020F0502020204030204" pitchFamily="34" charset="0"/>
-                <a:cs typeface="Calibri" panose="020F0502020204030204" pitchFamily="34" charset="0"/>
-              </a:rPr>
-              <a:t>/General/</a:t>
-            </a:r>
-            <a:r>
-              <a:rPr lang="en-US" b="0" u="sng" dirty="0" err="1">
-                <a:solidFill>
-                  <a:schemeClr val="bg1"/>
-                </a:solidFill>
-                <a:effectLst/>
-                <a:latin typeface="Calibri" panose="020F0502020204030204" pitchFamily="34" charset="0"/>
-                <a:cs typeface="Calibri" panose="020F0502020204030204" pitchFamily="34" charset="0"/>
-              </a:rPr>
-              <a:t>dieharder.php</a:t>
-            </a:r>
-            <a:endParaRPr lang="en-US" b="0" u="sng" dirty="0">
+            </a:br>
+            <a:endParaRPr lang="en-US" sz="2000" b="0" dirty="0">
               <a:solidFill>
                 <a:schemeClr val="bg1"/>
               </a:solidFill>
@@ -12283,7 +12743,18 @@
               </a:lnSpc>
               <a:buNone/>
             </a:pPr>
-            <a:endParaRPr lang="en-US" b="0" u="sng" dirty="0">
+            <a:r>
+              <a:rPr lang="en-US" sz="2000" b="1" dirty="0">
+                <a:solidFill>
+                  <a:schemeClr val="bg1"/>
+                </a:solidFill>
+                <a:effectLst/>
+                <a:latin typeface="Calibri" panose="020F0502020204030204" pitchFamily="34" charset="0"/>
+                <a:cs typeface="Calibri" panose="020F0502020204030204" pitchFamily="34" charset="0"/>
+              </a:rPr>
+              <a:t>- DIY - Build your own TRNG</a:t>
+            </a:r>
+            <a:endParaRPr lang="en-US" sz="2000" b="0" dirty="0">
               <a:solidFill>
                 <a:schemeClr val="bg1"/>
               </a:solidFill>
@@ -12299,32 +12770,47 @@
               </a:lnSpc>
               <a:buNone/>
             </a:pPr>
+            <a:endParaRPr lang="en-US" sz="2000" b="0" u="sng" dirty="0">
+              <a:solidFill>
+                <a:schemeClr val="accent1"/>
+              </a:solidFill>
+              <a:effectLst/>
+              <a:latin typeface="Calibri" panose="020F0502020204030204" pitchFamily="34" charset="0"/>
+              <a:cs typeface="Calibri" panose="020F0502020204030204" pitchFamily="34" charset="0"/>
+            </a:endParaRPr>
+          </a:p>
+          <a:p>
+            <a:pPr lvl="1">
+              <a:lnSpc>
+                <a:spcPts val="1350"/>
+              </a:lnSpc>
+            </a:pPr>
             <a:r>
               <a:rPr lang="en-US" b="0" u="sng" dirty="0">
                 <a:solidFill>
-                  <a:schemeClr val="bg1"/>
+                  <a:schemeClr val="accent1"/>
                 </a:solidFill>
                 <a:effectLst/>
                 <a:latin typeface="Calibri" panose="020F0502020204030204" pitchFamily="34" charset="0"/>
                 <a:cs typeface="Calibri" panose="020F0502020204030204" pitchFamily="34" charset="0"/>
               </a:rPr>
-              <a:t>https://</a:t>
+              <a:t>http://</a:t>
             </a:r>
             <a:r>
               <a:rPr lang="en-US" b="0" u="sng" dirty="0" err="1">
                 <a:solidFill>
-                  <a:schemeClr val="bg1"/>
+                  <a:schemeClr val="accent1"/>
                 </a:solidFill>
                 <a:effectLst/>
                 <a:latin typeface="Calibri" panose="020F0502020204030204" pitchFamily="34" charset="0"/>
                 <a:cs typeface="Calibri" panose="020F0502020204030204" pitchFamily="34" charset="0"/>
               </a:rPr>
-              <a:t>github.com</a:t>
+              <a:t>www.reallyreallyrandom.com</a:t>
             </a:r>
             <a:r>
               <a:rPr lang="en-US" b="0" u="sng" dirty="0">
                 <a:solidFill>
-                  <a:schemeClr val="bg1"/>
+                  <a:schemeClr val="accent1"/>
                 </a:solidFill>
                 <a:effectLst/>
                 <a:latin typeface="Calibri" panose="020F0502020204030204" pitchFamily="34" charset="0"/>
@@ -12335,39 +12821,17 @@
             <a:r>
               <a:rPr lang="en-US" b="0" u="sng" dirty="0" err="1">
                 <a:solidFill>
-                  <a:schemeClr val="bg1"/>
+                  <a:schemeClr val="accent1"/>
                 </a:solidFill>
                 <a:effectLst/>
                 <a:latin typeface="Calibri" panose="020F0502020204030204" pitchFamily="34" charset="0"/>
                 <a:cs typeface="Calibri" panose="020F0502020204030204" pitchFamily="34" charset="0"/>
               </a:rPr>
-              <a:t>seehuhn</a:t>
-            </a:r>
-            <a:r>
-              <a:rPr lang="en-US" b="0" u="sng" dirty="0">
-                <a:solidFill>
-                  <a:schemeClr val="bg1"/>
-                </a:solidFill>
-                <a:effectLst/>
-                <a:latin typeface="Calibri" panose="020F0502020204030204" pitchFamily="34" charset="0"/>
-                <a:cs typeface="Calibri" panose="020F0502020204030204" pitchFamily="34" charset="0"/>
-              </a:rPr>
-              <a:t>/</a:t>
-            </a:r>
-            <a:r>
-              <a:rPr lang="en-US" b="0" u="sng" dirty="0" err="1">
-                <a:solidFill>
-                  <a:schemeClr val="bg1"/>
-                </a:solidFill>
-                <a:effectLst/>
-                <a:latin typeface="Calibri" panose="020F0502020204030204" pitchFamily="34" charset="0"/>
-                <a:cs typeface="Calibri" panose="020F0502020204030204" pitchFamily="34" charset="0"/>
-              </a:rPr>
-              <a:t>dieharder</a:t>
+              <a:t>index.html</a:t>
             </a:r>
             <a:endParaRPr lang="en-US" b="0" u="sng" dirty="0">
               <a:solidFill>
-                <a:schemeClr val="bg1"/>
+                <a:schemeClr val="accent1"/>
               </a:solidFill>
               <a:effectLst/>
               <a:latin typeface="Calibri" panose="020F0502020204030204" pitchFamily="34" charset="0"/>
@@ -12382,7 +12846,7 @@
               <a:buNone/>
             </a:pPr>
             <a:br>
-              <a:rPr lang="en-US" b="0" dirty="0">
+              <a:rPr lang="en-US" sz="2000" b="0" dirty="0">
                 <a:solidFill>
                   <a:schemeClr val="bg1"/>
                 </a:solidFill>
@@ -12391,214 +12855,7 @@
                 <a:cs typeface="Calibri" panose="020F0502020204030204" pitchFamily="34" charset="0"/>
               </a:rPr>
             </a:br>
-            <a:endParaRPr lang="en-US" b="0" dirty="0">
-              <a:solidFill>
-                <a:schemeClr val="bg1"/>
-              </a:solidFill>
-              <a:effectLst/>
-              <a:latin typeface="Calibri" panose="020F0502020204030204" pitchFamily="34" charset="0"/>
-              <a:cs typeface="Calibri" panose="020F0502020204030204" pitchFamily="34" charset="0"/>
-            </a:endParaRPr>
-          </a:p>
-          <a:p>
-            <a:pPr>
-              <a:lnSpc>
-                <a:spcPts val="1350"/>
-              </a:lnSpc>
-              <a:buNone/>
-            </a:pPr>
-            <a:r>
-              <a:rPr lang="en-US" sz="2400" b="1" dirty="0">
-                <a:solidFill>
-                  <a:schemeClr val="bg1"/>
-                </a:solidFill>
-                <a:effectLst/>
-                <a:latin typeface="Calibri" panose="020F0502020204030204" pitchFamily="34" charset="0"/>
-                <a:cs typeface="Calibri" panose="020F0502020204030204" pitchFamily="34" charset="0"/>
-              </a:rPr>
-              <a:t>RANDOM.ORG offers true random numbers to anyone on the Internet</a:t>
-            </a:r>
-            <a:endParaRPr lang="en-US" sz="2400" b="0" dirty="0">
-              <a:solidFill>
-                <a:schemeClr val="bg1"/>
-              </a:solidFill>
-              <a:effectLst/>
-              <a:latin typeface="Calibri" panose="020F0502020204030204" pitchFamily="34" charset="0"/>
-              <a:cs typeface="Calibri" panose="020F0502020204030204" pitchFamily="34" charset="0"/>
-            </a:endParaRPr>
-          </a:p>
-          <a:p>
-            <a:pPr>
-              <a:lnSpc>
-                <a:spcPts val="1350"/>
-              </a:lnSpc>
-              <a:buNone/>
-            </a:pPr>
-            <a:r>
-              <a:rPr lang="en-US" b="0" u="sng" dirty="0">
-                <a:solidFill>
-                  <a:schemeClr val="bg1"/>
-                </a:solidFill>
-                <a:effectLst/>
-                <a:latin typeface="Calibri" panose="020F0502020204030204" pitchFamily="34" charset="0"/>
-                <a:cs typeface="Calibri" panose="020F0502020204030204" pitchFamily="34" charset="0"/>
-              </a:rPr>
-              <a:t>https://</a:t>
-            </a:r>
-            <a:r>
-              <a:rPr lang="en-US" b="0" u="sng" dirty="0" err="1">
-                <a:solidFill>
-                  <a:schemeClr val="bg1"/>
-                </a:solidFill>
-                <a:effectLst/>
-                <a:latin typeface="Calibri" panose="020F0502020204030204" pitchFamily="34" charset="0"/>
-                <a:cs typeface="Calibri" panose="020F0502020204030204" pitchFamily="34" charset="0"/>
-              </a:rPr>
-              <a:t>www.random.org</a:t>
-            </a:r>
-            <a:r>
-              <a:rPr lang="en-US" b="0" u="sng" dirty="0">
-                <a:solidFill>
-                  <a:schemeClr val="bg1"/>
-                </a:solidFill>
-                <a:effectLst/>
-                <a:latin typeface="Calibri" panose="020F0502020204030204" pitchFamily="34" charset="0"/>
-                <a:cs typeface="Calibri" panose="020F0502020204030204" pitchFamily="34" charset="0"/>
-              </a:rPr>
-              <a:t>/</a:t>
-            </a:r>
-          </a:p>
-          <a:p>
-            <a:pPr>
-              <a:lnSpc>
-                <a:spcPts val="1350"/>
-              </a:lnSpc>
-              <a:buNone/>
-            </a:pPr>
-            <a:br>
-              <a:rPr lang="en-US" b="0" dirty="0">
-                <a:solidFill>
-                  <a:schemeClr val="bg1"/>
-                </a:solidFill>
-                <a:effectLst/>
-                <a:latin typeface="Calibri" panose="020F0502020204030204" pitchFamily="34" charset="0"/>
-                <a:cs typeface="Calibri" panose="020F0502020204030204" pitchFamily="34" charset="0"/>
-              </a:rPr>
-            </a:br>
-            <a:endParaRPr lang="en-US" b="0" dirty="0">
-              <a:solidFill>
-                <a:schemeClr val="bg1"/>
-              </a:solidFill>
-              <a:effectLst/>
-              <a:latin typeface="Calibri" panose="020F0502020204030204" pitchFamily="34" charset="0"/>
-              <a:cs typeface="Calibri" panose="020F0502020204030204" pitchFamily="34" charset="0"/>
-            </a:endParaRPr>
-          </a:p>
-          <a:p>
-            <a:pPr>
-              <a:lnSpc>
-                <a:spcPts val="1350"/>
-              </a:lnSpc>
-              <a:buNone/>
-            </a:pPr>
-            <a:r>
-              <a:rPr lang="en-US" sz="2800" b="1" dirty="0">
-                <a:solidFill>
-                  <a:schemeClr val="bg1"/>
-                </a:solidFill>
-                <a:effectLst/>
-                <a:latin typeface="Calibri" panose="020F0502020204030204" pitchFamily="34" charset="0"/>
-                <a:cs typeface="Calibri" panose="020F0502020204030204" pitchFamily="34" charset="0"/>
-              </a:rPr>
-              <a:t>DIY - Build your own TRNG</a:t>
-            </a:r>
-            <a:endParaRPr lang="en-US" sz="2800" b="0" dirty="0">
-              <a:solidFill>
-                <a:schemeClr val="bg1"/>
-              </a:solidFill>
-              <a:effectLst/>
-              <a:latin typeface="Calibri" panose="020F0502020204030204" pitchFamily="34" charset="0"/>
-              <a:cs typeface="Calibri" panose="020F0502020204030204" pitchFamily="34" charset="0"/>
-            </a:endParaRPr>
-          </a:p>
-          <a:p>
-            <a:pPr>
-              <a:lnSpc>
-                <a:spcPts val="1350"/>
-              </a:lnSpc>
-              <a:buNone/>
-            </a:pPr>
-            <a:r>
-              <a:rPr lang="en-US" b="0" u="sng" dirty="0">
-                <a:solidFill>
-                  <a:schemeClr val="bg1"/>
-                </a:solidFill>
-                <a:effectLst/>
-                <a:latin typeface="Calibri" panose="020F0502020204030204" pitchFamily="34" charset="0"/>
-                <a:cs typeface="Calibri" panose="020F0502020204030204" pitchFamily="34" charset="0"/>
-              </a:rPr>
-              <a:t>http://</a:t>
-            </a:r>
-            <a:r>
-              <a:rPr lang="en-US" b="0" u="sng" dirty="0" err="1">
-                <a:solidFill>
-                  <a:schemeClr val="bg1"/>
-                </a:solidFill>
-                <a:effectLst/>
-                <a:latin typeface="Calibri" panose="020F0502020204030204" pitchFamily="34" charset="0"/>
-                <a:cs typeface="Calibri" panose="020F0502020204030204" pitchFamily="34" charset="0"/>
-              </a:rPr>
-              <a:t>www.reallyreallyrandom.com</a:t>
-            </a:r>
-            <a:r>
-              <a:rPr lang="en-US" b="0" u="sng" dirty="0">
-                <a:solidFill>
-                  <a:schemeClr val="bg1"/>
-                </a:solidFill>
-                <a:effectLst/>
-                <a:latin typeface="Calibri" panose="020F0502020204030204" pitchFamily="34" charset="0"/>
-                <a:cs typeface="Calibri" panose="020F0502020204030204" pitchFamily="34" charset="0"/>
-              </a:rPr>
-              <a:t>/</a:t>
-            </a:r>
-            <a:r>
-              <a:rPr lang="en-US" b="0" u="sng" dirty="0" err="1">
-                <a:solidFill>
-                  <a:schemeClr val="bg1"/>
-                </a:solidFill>
-                <a:effectLst/>
-                <a:latin typeface="Calibri" panose="020F0502020204030204" pitchFamily="34" charset="0"/>
-                <a:cs typeface="Calibri" panose="020F0502020204030204" pitchFamily="34" charset="0"/>
-              </a:rPr>
-              <a:t>index.html</a:t>
-            </a:r>
-            <a:endParaRPr lang="en-US" b="0" u="sng" dirty="0">
-              <a:solidFill>
-                <a:schemeClr val="bg1"/>
-              </a:solidFill>
-              <a:effectLst/>
-              <a:latin typeface="Calibri" panose="020F0502020204030204" pitchFamily="34" charset="0"/>
-              <a:cs typeface="Calibri" panose="020F0502020204030204" pitchFamily="34" charset="0"/>
-            </a:endParaRPr>
-          </a:p>
-          <a:p>
-            <a:pPr>
-              <a:lnSpc>
-                <a:spcPts val="1350"/>
-              </a:lnSpc>
-              <a:buNone/>
-            </a:pPr>
-            <a:br>
-              <a:rPr lang="en-US" b="0" dirty="0">
-                <a:solidFill>
-                  <a:schemeClr val="bg1"/>
-                </a:solidFill>
-                <a:effectLst/>
-                <a:latin typeface="Calibri" panose="020F0502020204030204" pitchFamily="34" charset="0"/>
-                <a:cs typeface="Calibri" panose="020F0502020204030204" pitchFamily="34" charset="0"/>
-              </a:rPr>
-            </a:br>
-            <a:endParaRPr lang="en-US" b="0" dirty="0">
+            <a:endParaRPr lang="en-US" sz="2000" b="0" dirty="0">
               <a:solidFill>
                 <a:schemeClr val="bg1"/>
               </a:solidFill>

</xml_diff>